<commit_message>
Various plot updates, before new fig 5
</commit_message>
<xml_diff>
--- a/plotting/figure_1.pptx
+++ b/plotting/figure_1.pptx
@@ -118,7 +118,7 @@
 <file path=ppt/revisionInfo.xml><?xml version="1.0" encoding="utf-8"?>
 <p1510:revInfo xmlns:a="http://schemas.openxmlformats.org/drawingml/2006/main" xmlns:r="http://schemas.openxmlformats.org/officeDocument/2006/relationships" xmlns:p1510="http://schemas.microsoft.com/office/powerpoint/2015/10/main">
   <p1510:revLst>
-    <p1510:client id="{BED072A7-6E24-4D01-BF38-C4B6B26205ED}" v="4" dt="2025-10-27T14:19:40.535"/>
+    <p1510:client id="{799370D6-427F-46D0-B65C-926C687486FF}" v="14" dt="2026-02-16T15:28:47.685"/>
   </p1510:revLst>
 </p1510:revInfo>
 </file>
@@ -126,274 +126,42 @@
 <file path=ppt/changesInfos/changesInfo1.xml><?xml version="1.0" encoding="utf-8"?>
 <pc:chgInfo xmlns:a="http://schemas.openxmlformats.org/drawingml/2006/main" xmlns:r="http://schemas.openxmlformats.org/officeDocument/2006/relationships" xmlns:ac="http://schemas.microsoft.com/office/drawing/2013/main/command" xmlns:pc="http://schemas.microsoft.com/office/powerpoint/2013/main/command">
   <pc:docChgLst>
-    <pc:chgData name="Doohan, Patrick E" userId="63cc5302-4d40-40c1-9c03-9c409d34e94b" providerId="ADAL" clId="{4F108F2F-553B-47DA-9C15-AF42B1EE77E2}"/>
-    <pc:docChg chg="undo custSel modSld">
-      <pc:chgData name="Doohan, Patrick E" userId="63cc5302-4d40-40c1-9c03-9c409d34e94b" providerId="ADAL" clId="{4F108F2F-553B-47DA-9C15-AF42B1EE77E2}" dt="2025-03-10T11:19:36.113" v="20" actId="1582"/>
-      <pc:docMkLst>
-        <pc:docMk/>
-      </pc:docMkLst>
-      <pc:sldChg chg="modSp mod">
-        <pc:chgData name="Doohan, Patrick E" userId="63cc5302-4d40-40c1-9c03-9c409d34e94b" providerId="ADAL" clId="{4F108F2F-553B-47DA-9C15-AF42B1EE77E2}" dt="2025-03-10T11:19:36.113" v="20" actId="1582"/>
-        <pc:sldMkLst>
-          <pc:docMk/>
-          <pc:sldMk cId="2445895467" sldId="256"/>
-        </pc:sldMkLst>
-      </pc:sldChg>
-    </pc:docChg>
-  </pc:docChgLst>
-  <pc:docChgLst>
-    <pc:chgData name="Doohan, Patrick E" userId="63cc5302-4d40-40c1-9c03-9c409d34e94b" providerId="ADAL" clId="{5ED36993-D7B9-46B9-9769-DD6A0191A476}"/>
-    <pc:docChg chg="undo redo custSel modSld">
-      <pc:chgData name="Doohan, Patrick E" userId="63cc5302-4d40-40c1-9c03-9c409d34e94b" providerId="ADAL" clId="{5ED36993-D7B9-46B9-9769-DD6A0191A476}" dt="2025-03-09T21:01:56.658" v="10126" actId="1037"/>
-      <pc:docMkLst>
-        <pc:docMk/>
-      </pc:docMkLst>
-      <pc:sldChg chg="addSp delSp modSp mod">
-        <pc:chgData name="Doohan, Patrick E" userId="63cc5302-4d40-40c1-9c03-9c409d34e94b" providerId="ADAL" clId="{5ED36993-D7B9-46B9-9769-DD6A0191A476}" dt="2025-03-09T21:01:56.658" v="10126" actId="1037"/>
-        <pc:sldMkLst>
-          <pc:docMk/>
-          <pc:sldMk cId="2445895467" sldId="256"/>
-        </pc:sldMkLst>
-      </pc:sldChg>
-    </pc:docChg>
-  </pc:docChgLst>
-  <pc:docChgLst>
-    <pc:chgData name="Doohan, Patrick E" userId="63cc5302-4d40-40c1-9c03-9c409d34e94b" providerId="ADAL" clId="{D2D22D9E-AB2D-4345-9646-4080277D4512}"/>
-    <pc:docChg chg="undo custSel modSld">
-      <pc:chgData name="Doohan, Patrick E" userId="63cc5302-4d40-40c1-9c03-9c409d34e94b" providerId="ADAL" clId="{D2D22D9E-AB2D-4345-9646-4080277D4512}" dt="2025-03-07T17:14:56.008" v="8340" actId="1036"/>
-      <pc:docMkLst>
-        <pc:docMk/>
-      </pc:docMkLst>
-      <pc:sldChg chg="addSp delSp modSp mod">
-        <pc:chgData name="Doohan, Patrick E" userId="63cc5302-4d40-40c1-9c03-9c409d34e94b" providerId="ADAL" clId="{D2D22D9E-AB2D-4345-9646-4080277D4512}" dt="2025-03-07T17:14:56.008" v="8340" actId="1036"/>
-        <pc:sldMkLst>
-          <pc:docMk/>
-          <pc:sldMk cId="2445895467" sldId="256"/>
-        </pc:sldMkLst>
-      </pc:sldChg>
-    </pc:docChg>
-  </pc:docChgLst>
-  <pc:docChgLst>
-    <pc:chgData name="Doohan, Patrick E" userId="63cc5302-4d40-40c1-9c03-9c409d34e94b" providerId="ADAL" clId="{A763A5F1-43F5-4D9C-A86C-C4B8FB8908C9}"/>
-    <pc:docChg chg="undo custSel modSld">
-      <pc:chgData name="Doohan, Patrick E" userId="63cc5302-4d40-40c1-9c03-9c409d34e94b" providerId="ADAL" clId="{A763A5F1-43F5-4D9C-A86C-C4B8FB8908C9}" dt="2025-06-30T13:26:53.771" v="350" actId="171"/>
-      <pc:docMkLst>
-        <pc:docMk/>
-      </pc:docMkLst>
-      <pc:sldChg chg="addSp delSp modSp mod modNotesTx">
-        <pc:chgData name="Doohan, Patrick E" userId="63cc5302-4d40-40c1-9c03-9c409d34e94b" providerId="ADAL" clId="{A763A5F1-43F5-4D9C-A86C-C4B8FB8908C9}" dt="2025-06-30T13:26:53.771" v="350" actId="171"/>
-        <pc:sldMkLst>
-          <pc:docMk/>
-          <pc:sldMk cId="2445895467" sldId="256"/>
-        </pc:sldMkLst>
-      </pc:sldChg>
-    </pc:docChg>
-  </pc:docChgLst>
-  <pc:docChgLst>
     <pc:chgData name="Doohan, Patrick E" userId="63cc5302-4d40-40c1-9c03-9c409d34e94b" providerId="ADAL" clId="{70E87B4F-4617-4322-AE14-14ADB5415D44}"/>
     <pc:docChg chg="undo custSel modSld">
-      <pc:chgData name="Doohan, Patrick E" userId="63cc5302-4d40-40c1-9c03-9c409d34e94b" providerId="ADAL" clId="{70E87B4F-4617-4322-AE14-14ADB5415D44}" dt="2025-10-27T14:25:43.354" v="517" actId="207"/>
+      <pc:chgData name="Doohan, Patrick E" userId="63cc5302-4d40-40c1-9c03-9c409d34e94b" providerId="ADAL" clId="{70E87B4F-4617-4322-AE14-14ADB5415D44}" dt="2026-02-16T15:34:12.752" v="581" actId="20577"/>
       <pc:docMkLst>
         <pc:docMk/>
       </pc:docMkLst>
       <pc:sldChg chg="addSp modSp mod">
-        <pc:chgData name="Doohan, Patrick E" userId="63cc5302-4d40-40c1-9c03-9c409d34e94b" providerId="ADAL" clId="{70E87B4F-4617-4322-AE14-14ADB5415D44}" dt="2025-10-27T14:25:43.354" v="517" actId="207"/>
+        <pc:chgData name="Doohan, Patrick E" userId="63cc5302-4d40-40c1-9c03-9c409d34e94b" providerId="ADAL" clId="{70E87B4F-4617-4322-AE14-14ADB5415D44}" dt="2026-02-16T15:34:12.752" v="581" actId="20577"/>
         <pc:sldMkLst>
           <pc:docMk/>
           <pc:sldMk cId="2445895467" sldId="256"/>
         </pc:sldMkLst>
         <pc:spChg chg="mod">
-          <ac:chgData name="Doohan, Patrick E" userId="63cc5302-4d40-40c1-9c03-9c409d34e94b" providerId="ADAL" clId="{70E87B4F-4617-4322-AE14-14ADB5415D44}" dt="2025-10-27T14:10:32.846" v="343" actId="14100"/>
+          <ac:chgData name="Doohan, Patrick E" userId="63cc5302-4d40-40c1-9c03-9c409d34e94b" providerId="ADAL" clId="{70E87B4F-4617-4322-AE14-14ADB5415D44}" dt="2026-02-16T15:34:12.752" v="581" actId="20577"/>
           <ac:spMkLst>
             <pc:docMk/>
             <pc:sldMk cId="2445895467" sldId="256"/>
-            <ac:spMk id="12" creationId="{3E27AD03-0FAB-1481-5390-0A8737A184BD}"/>
+            <ac:spMk id="475" creationId="{7AC2AB27-7DB3-AA07-DD70-706261CFD5F3}"/>
           </ac:spMkLst>
         </pc:spChg>
-        <pc:spChg chg="mod">
-          <ac:chgData name="Doohan, Patrick E" userId="63cc5302-4d40-40c1-9c03-9c409d34e94b" providerId="ADAL" clId="{70E87B4F-4617-4322-AE14-14ADB5415D44}" dt="2025-10-27T14:16:21.704" v="352" actId="207"/>
-          <ac:spMkLst>
+        <pc:picChg chg="mod">
+          <ac:chgData name="Doohan, Patrick E" userId="63cc5302-4d40-40c1-9c03-9c409d34e94b" providerId="ADAL" clId="{70E87B4F-4617-4322-AE14-14ADB5415D44}" dt="2026-02-16T15:28:47.685" v="531" actId="14826"/>
+          <ac:picMkLst>
             <pc:docMk/>
             <pc:sldMk cId="2445895467" sldId="256"/>
-            <ac:spMk id="141" creationId="{B42A1FC1-3F5F-3516-A20E-5E3F4313A4C3}"/>
-          </ac:spMkLst>
-        </pc:spChg>
-        <pc:spChg chg="mod">
-          <ac:chgData name="Doohan, Patrick E" userId="63cc5302-4d40-40c1-9c03-9c409d34e94b" providerId="ADAL" clId="{70E87B4F-4617-4322-AE14-14ADB5415D44}" dt="2025-10-27T14:25:34.017" v="513" actId="207"/>
-          <ac:spMkLst>
+            <ac:picMk id="2" creationId="{FFC319A7-1BF8-22ED-15C2-A3795F551BA2}"/>
+          </ac:picMkLst>
+        </pc:picChg>
+        <pc:picChg chg="mod">
+          <ac:chgData name="Doohan, Patrick E" userId="63cc5302-4d40-40c1-9c03-9c409d34e94b" providerId="ADAL" clId="{70E87B4F-4617-4322-AE14-14ADB5415D44}" dt="2026-02-16T15:27:51.959" v="524" actId="14826"/>
+          <ac:picMkLst>
             <pc:docMk/>
             <pc:sldMk cId="2445895467" sldId="256"/>
-            <ac:spMk id="144" creationId="{1FAEBD00-1776-05E4-3A49-4355CE2990A0}"/>
-          </ac:spMkLst>
-        </pc:spChg>
-        <pc:spChg chg="mod">
-          <ac:chgData name="Doohan, Patrick E" userId="63cc5302-4d40-40c1-9c03-9c409d34e94b" providerId="ADAL" clId="{70E87B4F-4617-4322-AE14-14ADB5415D44}" dt="2025-10-27T14:16:49.781" v="354" actId="13926"/>
-          <ac:spMkLst>
-            <pc:docMk/>
-            <pc:sldMk cId="2445895467" sldId="256"/>
-            <ac:spMk id="150" creationId="{D6DF7650-0039-8A4E-FA17-8B13CDF45343}"/>
-          </ac:spMkLst>
-        </pc:spChg>
-        <pc:spChg chg="mod">
-          <ac:chgData name="Doohan, Patrick E" userId="63cc5302-4d40-40c1-9c03-9c409d34e94b" providerId="ADAL" clId="{70E87B4F-4617-4322-AE14-14ADB5415D44}" dt="2025-10-27T14:25:36.345" v="514" actId="207"/>
-          <ac:spMkLst>
-            <pc:docMk/>
-            <pc:sldMk cId="2445895467" sldId="256"/>
-            <ac:spMk id="151" creationId="{EC95F1A5-88F0-72BE-4EA4-96EACF3B0648}"/>
-          </ac:spMkLst>
-        </pc:spChg>
-        <pc:spChg chg="mod">
-          <ac:chgData name="Doohan, Patrick E" userId="63cc5302-4d40-40c1-9c03-9c409d34e94b" providerId="ADAL" clId="{70E87B4F-4617-4322-AE14-14ADB5415D44}" dt="2025-10-27T14:25:43.354" v="517" actId="207"/>
-          <ac:spMkLst>
-            <pc:docMk/>
-            <pc:sldMk cId="2445895467" sldId="256"/>
-            <ac:spMk id="154" creationId="{23B0101E-65DF-13A1-3A79-1E36AB56937A}"/>
-          </ac:spMkLst>
-        </pc:spChg>
-        <pc:spChg chg="mod">
-          <ac:chgData name="Doohan, Patrick E" userId="63cc5302-4d40-40c1-9c03-9c409d34e94b" providerId="ADAL" clId="{70E87B4F-4617-4322-AE14-14ADB5415D44}" dt="2025-10-27T14:25:40.157" v="516" actId="207"/>
-          <ac:spMkLst>
-            <pc:docMk/>
-            <pc:sldMk cId="2445895467" sldId="256"/>
-            <ac:spMk id="157" creationId="{47869D64-8257-6EF1-6344-4B18FE952887}"/>
-          </ac:spMkLst>
-        </pc:spChg>
-        <pc:spChg chg="mod">
-          <ac:chgData name="Doohan, Patrick E" userId="63cc5302-4d40-40c1-9c03-9c409d34e94b" providerId="ADAL" clId="{70E87B4F-4617-4322-AE14-14ADB5415D44}" dt="2025-10-27T14:25:30.563" v="512" actId="207"/>
-          <ac:spMkLst>
-            <pc:docMk/>
-            <pc:sldMk cId="2445895467" sldId="256"/>
-            <ac:spMk id="160" creationId="{8AB1CD61-ADD6-D5E6-4F90-C732A257546C}"/>
-          </ac:spMkLst>
-        </pc:spChg>
-        <pc:spChg chg="mod">
-          <ac:chgData name="Doohan, Patrick E" userId="63cc5302-4d40-40c1-9c03-9c409d34e94b" providerId="ADAL" clId="{70E87B4F-4617-4322-AE14-14ADB5415D44}" dt="2025-10-27T14:25:38.376" v="515" actId="207"/>
-          <ac:spMkLst>
-            <pc:docMk/>
-            <pc:sldMk cId="2445895467" sldId="256"/>
-            <ac:spMk id="163" creationId="{05C7E899-CC5F-8640-EE9E-BF738A154FE3}"/>
-          </ac:spMkLst>
-        </pc:spChg>
-        <pc:spChg chg="mod">
-          <ac:chgData name="Doohan, Patrick E" userId="63cc5302-4d40-40c1-9c03-9c409d34e94b" providerId="ADAL" clId="{70E87B4F-4617-4322-AE14-14ADB5415D44}" dt="2025-10-27T14:25:28.345" v="511" actId="207"/>
-          <ac:spMkLst>
-            <pc:docMk/>
-            <pc:sldMk cId="2445895467" sldId="256"/>
-            <ac:spMk id="166" creationId="{03BEC6C3-4EA4-D427-6199-9FEDED99B7C8}"/>
-          </ac:spMkLst>
-        </pc:spChg>
-        <pc:spChg chg="mod">
-          <ac:chgData name="Doohan, Patrick E" userId="63cc5302-4d40-40c1-9c03-9c409d34e94b" providerId="ADAL" clId="{70E87B4F-4617-4322-AE14-14ADB5415D44}" dt="2025-10-27T14:17:01.030" v="355" actId="13926"/>
-          <ac:spMkLst>
-            <pc:docMk/>
-            <pc:sldMk cId="2445895467" sldId="256"/>
-            <ac:spMk id="177" creationId="{A966334A-F01C-7C0A-7BC8-409AF807416D}"/>
-          </ac:spMkLst>
-        </pc:spChg>
-        <pc:spChg chg="mod">
-          <ac:chgData name="Doohan, Patrick E" userId="63cc5302-4d40-40c1-9c03-9c409d34e94b" providerId="ADAL" clId="{70E87B4F-4617-4322-AE14-14ADB5415D44}" dt="2025-10-27T14:25:25.861" v="510" actId="207"/>
-          <ac:spMkLst>
-            <pc:docMk/>
-            <pc:sldMk cId="2445895467" sldId="256"/>
-            <ac:spMk id="178" creationId="{CEA5102E-393A-11FE-76A3-7A27BC6680C8}"/>
-          </ac:spMkLst>
-        </pc:spChg>
-        <pc:spChg chg="mod">
-          <ac:chgData name="Doohan, Patrick E" userId="63cc5302-4d40-40c1-9c03-9c409d34e94b" providerId="ADAL" clId="{70E87B4F-4617-4322-AE14-14ADB5415D44}" dt="2025-10-27T14:12:13.738" v="345" actId="207"/>
-          <ac:spMkLst>
-            <pc:docMk/>
-            <pc:sldMk cId="2445895467" sldId="256"/>
-            <ac:spMk id="220" creationId="{9C2C6855-B58C-92D4-8A75-74F2A3A78475}"/>
-          </ac:spMkLst>
-        </pc:spChg>
-        <pc:spChg chg="mod">
-          <ac:chgData name="Doohan, Patrick E" userId="63cc5302-4d40-40c1-9c03-9c409d34e94b" providerId="ADAL" clId="{70E87B4F-4617-4322-AE14-14ADB5415D44}" dt="2025-10-27T14:12:51.317" v="347" actId="207"/>
-          <ac:spMkLst>
-            <pc:docMk/>
-            <pc:sldMk cId="2445895467" sldId="256"/>
-            <ac:spMk id="222" creationId="{CF1BFE51-894F-DB4B-33F1-C52605CC2C19}"/>
-          </ac:spMkLst>
-        </pc:spChg>
-        <pc:spChg chg="mod">
-          <ac:chgData name="Doohan, Patrick E" userId="63cc5302-4d40-40c1-9c03-9c409d34e94b" providerId="ADAL" clId="{70E87B4F-4617-4322-AE14-14ADB5415D44}" dt="2025-10-27T14:12:46.676" v="346" actId="207"/>
-          <ac:spMkLst>
-            <pc:docMk/>
-            <pc:sldMk cId="2445895467" sldId="256"/>
-            <ac:spMk id="225" creationId="{09972620-E1B7-CA38-2834-F33DC311D996}"/>
-          </ac:spMkLst>
-        </pc:spChg>
-        <pc:spChg chg="mod">
-          <ac:chgData name="Doohan, Patrick E" userId="63cc5302-4d40-40c1-9c03-9c409d34e94b" providerId="ADAL" clId="{70E87B4F-4617-4322-AE14-14ADB5415D44}" dt="2025-10-27T14:11:39.958" v="344" actId="207"/>
-          <ac:spMkLst>
-            <pc:docMk/>
-            <pc:sldMk cId="2445895467" sldId="256"/>
-            <ac:spMk id="226" creationId="{F221FAF0-8AA4-5FAF-4F2C-4E316C1DFA1F}"/>
-          </ac:spMkLst>
-        </pc:spChg>
-        <pc:spChg chg="mod">
-          <ac:chgData name="Doohan, Patrick E" userId="63cc5302-4d40-40c1-9c03-9c409d34e94b" providerId="ADAL" clId="{70E87B4F-4617-4322-AE14-14ADB5415D44}" dt="2025-10-27T14:13:34.452" v="349" actId="207"/>
-          <ac:spMkLst>
-            <pc:docMk/>
-            <pc:sldMk cId="2445895467" sldId="256"/>
-            <ac:spMk id="341" creationId="{2786322E-EE0A-BE37-8B04-A751D9B33E72}"/>
-          </ac:spMkLst>
-        </pc:spChg>
-        <pc:spChg chg="mod">
-          <ac:chgData name="Doohan, Patrick E" userId="63cc5302-4d40-40c1-9c03-9c409d34e94b" providerId="ADAL" clId="{70E87B4F-4617-4322-AE14-14ADB5415D44}" dt="2025-10-27T14:13:39.032" v="350" actId="207"/>
-          <ac:spMkLst>
-            <pc:docMk/>
-            <pc:sldMk cId="2445895467" sldId="256"/>
-            <ac:spMk id="376" creationId="{176DEFEE-844F-445E-2879-A7CE12246C44}"/>
-          </ac:spMkLst>
-        </pc:spChg>
-        <pc:spChg chg="add mod">
-          <ac:chgData name="Doohan, Patrick E" userId="63cc5302-4d40-40c1-9c03-9c409d34e94b" providerId="ADAL" clId="{70E87B4F-4617-4322-AE14-14ADB5415D44}" dt="2025-10-27T14:07:58.460" v="99" actId="1035"/>
-          <ac:spMkLst>
-            <pc:docMk/>
-            <pc:sldMk cId="2445895467" sldId="256"/>
-            <ac:spMk id="515" creationId="{9942EABE-E5B3-25C3-AD77-C530CAF4F4B1}"/>
-          </ac:spMkLst>
-        </pc:spChg>
-        <pc:spChg chg="add mod">
-          <ac:chgData name="Doohan, Patrick E" userId="63cc5302-4d40-40c1-9c03-9c409d34e94b" providerId="ADAL" clId="{70E87B4F-4617-4322-AE14-14ADB5415D44}" dt="2025-10-27T14:08:36.925" v="185" actId="1038"/>
-          <ac:spMkLst>
-            <pc:docMk/>
-            <pc:sldMk cId="2445895467" sldId="256"/>
-            <ac:spMk id="516" creationId="{DE762D25-930D-F289-0A77-C3B8028D14F3}"/>
-          </ac:spMkLst>
-        </pc:spChg>
-        <pc:spChg chg="add mod">
-          <ac:chgData name="Doohan, Patrick E" userId="63cc5302-4d40-40c1-9c03-9c409d34e94b" providerId="ADAL" clId="{70E87B4F-4617-4322-AE14-14ADB5415D44}" dt="2025-10-27T14:09:39.763" v="336" actId="1038"/>
-          <ac:spMkLst>
-            <pc:docMk/>
-            <pc:sldMk cId="2445895467" sldId="256"/>
-            <ac:spMk id="533" creationId="{07271C7F-8A94-5B9C-3D66-93D3F489F00F}"/>
-          </ac:spMkLst>
-        </pc:spChg>
-        <pc:spChg chg="add mod">
-          <ac:chgData name="Doohan, Patrick E" userId="63cc5302-4d40-40c1-9c03-9c409d34e94b" providerId="ADAL" clId="{70E87B4F-4617-4322-AE14-14ADB5415D44}" dt="2025-10-27T14:09:39.763" v="336" actId="1038"/>
-          <ac:spMkLst>
-            <pc:docMk/>
-            <pc:sldMk cId="2445895467" sldId="256"/>
-            <ac:spMk id="534" creationId="{85DF038B-042F-D68C-ABF3-2E087678E333}"/>
-          </ac:spMkLst>
-        </pc:spChg>
-        <pc:cxnChg chg="add mod">
-          <ac:chgData name="Doohan, Patrick E" userId="63cc5302-4d40-40c1-9c03-9c409d34e94b" providerId="ADAL" clId="{70E87B4F-4617-4322-AE14-14ADB5415D44}" dt="2025-10-27T14:19:35.581" v="424" actId="1038"/>
-          <ac:cxnSpMkLst>
-            <pc:docMk/>
-            <pc:sldMk cId="2445895467" sldId="256"/>
-            <ac:cxnSpMk id="535" creationId="{4A1326FD-ABF7-2FA2-12AC-468A20C0ECD2}"/>
-          </ac:cxnSpMkLst>
-        </pc:cxnChg>
-        <pc:cxnChg chg="add mod">
-          <ac:chgData name="Doohan, Patrick E" userId="63cc5302-4d40-40c1-9c03-9c409d34e94b" providerId="ADAL" clId="{70E87B4F-4617-4322-AE14-14ADB5415D44}" dt="2025-10-27T14:20:20.837" v="508" actId="14100"/>
-          <ac:cxnSpMkLst>
-            <pc:docMk/>
-            <pc:sldMk cId="2445895467" sldId="256"/>
-            <ac:cxnSpMk id="537" creationId="{262C38AA-6E77-F903-CB1B-16AA95B2D388}"/>
-          </ac:cxnSpMkLst>
-        </pc:cxnChg>
+            <ac:picMk id="17" creationId="{8675D29F-9856-1B61-3A0B-0274C10E079D}"/>
+          </ac:picMkLst>
+        </pc:picChg>
       </pc:sldChg>
     </pc:docChg>
   </pc:docChgLst>
@@ -482,7 +250,7 @@
           <a:p>
             <a:fld id="{B537B997-3BAF-428A-BD7E-EF61D113E801}" type="datetimeFigureOut">
               <a:rPr lang="en-GB" smtClean="0"/>
-              <a:t>27/10/2025</a:t>
+              <a:t>16/02/2026</a:t>
             </a:fld>
             <a:endParaRPr lang="en-GB"/>
           </a:p>
@@ -991,7 +759,7 @@
           <a:p>
             <a:fld id="{A18D3707-5733-4B01-BC83-BABD02B2F3C7}" type="datetimeFigureOut">
               <a:rPr lang="en-GB" smtClean="0"/>
-              <a:t>27/10/2025</a:t>
+              <a:t>16/02/2026</a:t>
             </a:fld>
             <a:endParaRPr lang="en-GB"/>
           </a:p>
@@ -1161,7 +929,7 @@
           <a:p>
             <a:fld id="{A18D3707-5733-4B01-BC83-BABD02B2F3C7}" type="datetimeFigureOut">
               <a:rPr lang="en-GB" smtClean="0"/>
-              <a:t>27/10/2025</a:t>
+              <a:t>16/02/2026</a:t>
             </a:fld>
             <a:endParaRPr lang="en-GB"/>
           </a:p>
@@ -1341,7 +1109,7 @@
           <a:p>
             <a:fld id="{A18D3707-5733-4B01-BC83-BABD02B2F3C7}" type="datetimeFigureOut">
               <a:rPr lang="en-GB" smtClean="0"/>
-              <a:t>27/10/2025</a:t>
+              <a:t>16/02/2026</a:t>
             </a:fld>
             <a:endParaRPr lang="en-GB"/>
           </a:p>
@@ -1511,7 +1279,7 @@
           <a:p>
             <a:fld id="{A18D3707-5733-4B01-BC83-BABD02B2F3C7}" type="datetimeFigureOut">
               <a:rPr lang="en-GB" smtClean="0"/>
-              <a:t>27/10/2025</a:t>
+              <a:t>16/02/2026</a:t>
             </a:fld>
             <a:endParaRPr lang="en-GB"/>
           </a:p>
@@ -1757,7 +1525,7 @@
           <a:p>
             <a:fld id="{A18D3707-5733-4B01-BC83-BABD02B2F3C7}" type="datetimeFigureOut">
               <a:rPr lang="en-GB" smtClean="0"/>
-              <a:t>27/10/2025</a:t>
+              <a:t>16/02/2026</a:t>
             </a:fld>
             <a:endParaRPr lang="en-GB"/>
           </a:p>
@@ -1989,7 +1757,7 @@
           <a:p>
             <a:fld id="{A18D3707-5733-4B01-BC83-BABD02B2F3C7}" type="datetimeFigureOut">
               <a:rPr lang="en-GB" smtClean="0"/>
-              <a:t>27/10/2025</a:t>
+              <a:t>16/02/2026</a:t>
             </a:fld>
             <a:endParaRPr lang="en-GB"/>
           </a:p>
@@ -2356,7 +2124,7 @@
           <a:p>
             <a:fld id="{A18D3707-5733-4B01-BC83-BABD02B2F3C7}" type="datetimeFigureOut">
               <a:rPr lang="en-GB" smtClean="0"/>
-              <a:t>27/10/2025</a:t>
+              <a:t>16/02/2026</a:t>
             </a:fld>
             <a:endParaRPr lang="en-GB"/>
           </a:p>
@@ -2474,7 +2242,7 @@
           <a:p>
             <a:fld id="{A18D3707-5733-4B01-BC83-BABD02B2F3C7}" type="datetimeFigureOut">
               <a:rPr lang="en-GB" smtClean="0"/>
-              <a:t>27/10/2025</a:t>
+              <a:t>16/02/2026</a:t>
             </a:fld>
             <a:endParaRPr lang="en-GB"/>
           </a:p>
@@ -2569,7 +2337,7 @@
           <a:p>
             <a:fld id="{A18D3707-5733-4B01-BC83-BABD02B2F3C7}" type="datetimeFigureOut">
               <a:rPr lang="en-GB" smtClean="0"/>
-              <a:t>27/10/2025</a:t>
+              <a:t>16/02/2026</a:t>
             </a:fld>
             <a:endParaRPr lang="en-GB"/>
           </a:p>
@@ -2846,7 +2614,7 @@
           <a:p>
             <a:fld id="{A18D3707-5733-4B01-BC83-BABD02B2F3C7}" type="datetimeFigureOut">
               <a:rPr lang="en-GB" smtClean="0"/>
-              <a:t>27/10/2025</a:t>
+              <a:t>16/02/2026</a:t>
             </a:fld>
             <a:endParaRPr lang="en-GB"/>
           </a:p>
@@ -3103,7 +2871,7 @@
           <a:p>
             <a:fld id="{A18D3707-5733-4B01-BC83-BABD02B2F3C7}" type="datetimeFigureOut">
               <a:rPr lang="en-GB" smtClean="0"/>
-              <a:t>27/10/2025</a:t>
+              <a:t>16/02/2026</a:t>
             </a:fld>
             <a:endParaRPr lang="en-GB"/>
           </a:p>
@@ -3316,7 +3084,7 @@
           <a:p>
             <a:fld id="{A18D3707-5733-4B01-BC83-BABD02B2F3C7}" type="datetimeFigureOut">
               <a:rPr lang="en-GB" smtClean="0"/>
-              <a:t>27/10/2025</a:t>
+              <a:t>16/02/2026</a:t>
             </a:fld>
             <a:endParaRPr lang="en-GB"/>
           </a:p>
@@ -14493,14 +14261,13 @@
         </p:nvPicPr>
         <p:blipFill>
           <a:blip r:embed="rId22"/>
-          <a:stretch>
-            <a:fillRect/>
-          </a:stretch>
+          <a:srcRect/>
+          <a:stretch/>
         </p:blipFill>
         <p:spPr>
           <a:xfrm>
-            <a:off x="2816395" y="1057274"/>
-            <a:ext cx="616745" cy="435769"/>
+            <a:off x="2816395" y="1070030"/>
+            <a:ext cx="616745" cy="410257"/>
           </a:xfrm>
           <a:prstGeom prst="rect">
             <a:avLst/>
@@ -14523,14 +14290,13 @@
         </p:nvPicPr>
         <p:blipFill>
           <a:blip r:embed="rId23"/>
-          <a:stretch>
-            <a:fillRect/>
-          </a:stretch>
+          <a:srcRect/>
+          <a:stretch/>
         </p:blipFill>
         <p:spPr>
           <a:xfrm>
-            <a:off x="510536" y="1056813"/>
-            <a:ext cx="622654" cy="438761"/>
+            <a:off x="510536" y="1069099"/>
+            <a:ext cx="622654" cy="414188"/>
           </a:xfrm>
           <a:prstGeom prst="rect">
             <a:avLst/>
@@ -20388,7 +20154,7 @@
         <p:spPr>
           <a:xfrm>
             <a:off x="770977" y="1985681"/>
-            <a:ext cx="706522" cy="184666"/>
+            <a:ext cx="706522" cy="276999"/>
           </a:xfrm>
           <a:prstGeom prst="rect">
             <a:avLst/>
@@ -20434,6 +20200,24 @@
                 <a:latin typeface="LM Roman 9" panose="00000500000000000000" pitchFamily="50" charset="0"/>
               </a:rPr>
               <a:t>Testing Rate</a:t>
+            </a:r>
+          </a:p>
+          <a:p>
+            <a:pPr marL="88900" indent="-88900">
+              <a:buFont typeface="Arial" panose="020B0604020202020204" pitchFamily="34" charset="0"/>
+              <a:buChar char="•"/>
+            </a:pPr>
+            <a:r>
+              <a:rPr lang="en-GB" sz="300" dirty="0">
+                <a:solidFill>
+                  <a:schemeClr val="accent6">
+                    <a:lumMod val="60000"/>
+                    <a:lumOff val="40000"/>
+                  </a:schemeClr>
+                </a:solidFill>
+                <a:latin typeface="LM Roman 9" panose="00000500000000000000" pitchFamily="50" charset="0"/>
+              </a:rPr>
+              <a:t>Infection Ascertainment Ratio</a:t>
             </a:r>
           </a:p>
         </p:txBody>

</xml_diff>

<commit_message>
swapped Fig 5b and c
</commit_message>
<xml_diff>
--- a/plotting/figure_1.pptx
+++ b/plotting/figure_1.pptx
@@ -115,35 +115,51 @@
 </p:presentation>
 </file>
 
-<file path=ppt/revisionInfo.xml><?xml version="1.0" encoding="utf-8"?>
-<p1510:revInfo xmlns:a="http://schemas.openxmlformats.org/drawingml/2006/main" xmlns:r="http://schemas.openxmlformats.org/officeDocument/2006/relationships" xmlns:p1510="http://schemas.microsoft.com/office/powerpoint/2015/10/main">
-  <p1510:revLst>
-    <p1510:client id="{799370D6-427F-46D0-B65C-926C687486FF}" v="14" dt="2026-02-16T15:28:47.685"/>
-  </p1510:revLst>
-</p1510:revInfo>
-</file>
-
 <file path=ppt/changesInfos/changesInfo1.xml><?xml version="1.0" encoding="utf-8"?>
 <pc:chgInfo xmlns:a="http://schemas.openxmlformats.org/drawingml/2006/main" xmlns:r="http://schemas.openxmlformats.org/officeDocument/2006/relationships" xmlns:ac="http://schemas.microsoft.com/office/drawing/2013/main/command" xmlns:pc="http://schemas.microsoft.com/office/powerpoint/2013/main/command">
   <pc:docChgLst>
     <pc:chgData name="Doohan, Patrick E" userId="63cc5302-4d40-40c1-9c03-9c409d34e94b" providerId="ADAL" clId="{70E87B4F-4617-4322-AE14-14ADB5415D44}"/>
     <pc:docChg chg="undo custSel modSld">
-      <pc:chgData name="Doohan, Patrick E" userId="63cc5302-4d40-40c1-9c03-9c409d34e94b" providerId="ADAL" clId="{70E87B4F-4617-4322-AE14-14ADB5415D44}" dt="2026-02-16T15:34:12.752" v="581" actId="20577"/>
+      <pc:chgData name="Doohan, Patrick E" userId="63cc5302-4d40-40c1-9c03-9c409d34e94b" providerId="ADAL" clId="{70E87B4F-4617-4322-AE14-14ADB5415D44}" dt="2026-03-09T11:54:36.383" v="655" actId="20577"/>
       <pc:docMkLst>
         <pc:docMk/>
       </pc:docMkLst>
       <pc:sldChg chg="addSp modSp mod">
-        <pc:chgData name="Doohan, Patrick E" userId="63cc5302-4d40-40c1-9c03-9c409d34e94b" providerId="ADAL" clId="{70E87B4F-4617-4322-AE14-14ADB5415D44}" dt="2026-02-16T15:34:12.752" v="581" actId="20577"/>
+        <pc:chgData name="Doohan, Patrick E" userId="63cc5302-4d40-40c1-9c03-9c409d34e94b" providerId="ADAL" clId="{70E87B4F-4617-4322-AE14-14ADB5415D44}" dt="2026-03-09T11:54:36.383" v="655" actId="20577"/>
         <pc:sldMkLst>
           <pc:docMk/>
           <pc:sldMk cId="2445895467" sldId="256"/>
         </pc:sldMkLst>
         <pc:spChg chg="mod">
-          <ac:chgData name="Doohan, Patrick E" userId="63cc5302-4d40-40c1-9c03-9c409d34e94b" providerId="ADAL" clId="{70E87B4F-4617-4322-AE14-14ADB5415D44}" dt="2026-02-16T15:34:12.752" v="581" actId="20577"/>
+          <ac:chgData name="Doohan, Patrick E" userId="63cc5302-4d40-40c1-9c03-9c409d34e94b" providerId="ADAL" clId="{70E87B4F-4617-4322-AE14-14ADB5415D44}" dt="2026-03-09T11:50:45.164" v="609" actId="20577"/>
+          <ac:spMkLst>
+            <pc:docMk/>
+            <pc:sldMk cId="2445895467" sldId="256"/>
+            <ac:spMk id="467" creationId="{1346ACAB-2B5A-ABDB-D5D7-14648162A454}"/>
+          </ac:spMkLst>
+        </pc:spChg>
+        <pc:spChg chg="mod">
+          <ac:chgData name="Doohan, Patrick E" userId="63cc5302-4d40-40c1-9c03-9c409d34e94b" providerId="ADAL" clId="{70E87B4F-4617-4322-AE14-14ADB5415D44}" dt="2026-03-09T11:54:36.383" v="655" actId="20577"/>
           <ac:spMkLst>
             <pc:docMk/>
             <pc:sldMk cId="2445895467" sldId="256"/>
             <ac:spMk id="475" creationId="{7AC2AB27-7DB3-AA07-DD70-706261CFD5F3}"/>
+          </ac:spMkLst>
+        </pc:spChg>
+        <pc:spChg chg="mod">
+          <ac:chgData name="Doohan, Patrick E" userId="63cc5302-4d40-40c1-9c03-9c409d34e94b" providerId="ADAL" clId="{70E87B4F-4617-4322-AE14-14ADB5415D44}" dt="2026-03-09T11:51:31.843" v="637" actId="20577"/>
+          <ac:spMkLst>
+            <pc:docMk/>
+            <pc:sldMk cId="2445895467" sldId="256"/>
+            <ac:spMk id="480" creationId="{181AE0F6-8AA1-1348-A5FE-5521603C13E1}"/>
+          </ac:spMkLst>
+        </pc:spChg>
+        <pc:spChg chg="mod">
+          <ac:chgData name="Doohan, Patrick E" userId="63cc5302-4d40-40c1-9c03-9c409d34e94b" providerId="ADAL" clId="{70E87B4F-4617-4322-AE14-14ADB5415D44}" dt="2026-03-09T11:51:37.438" v="641" actId="20577"/>
+          <ac:spMkLst>
+            <pc:docMk/>
+            <pc:sldMk cId="2445895467" sldId="256"/>
+            <ac:spMk id="486" creationId="{3B4706F9-3A32-BB9C-8193-7A22108E5AD6}"/>
           </ac:spMkLst>
         </pc:spChg>
         <pc:picChg chg="mod">
@@ -250,7 +266,7 @@
           <a:p>
             <a:fld id="{B537B997-3BAF-428A-BD7E-EF61D113E801}" type="datetimeFigureOut">
               <a:rPr lang="en-GB" smtClean="0"/>
-              <a:t>16/02/2026</a:t>
+              <a:t>09/03/2026</a:t>
             </a:fld>
             <a:endParaRPr lang="en-GB"/>
           </a:p>
@@ -759,7 +775,7 @@
           <a:p>
             <a:fld id="{A18D3707-5733-4B01-BC83-BABD02B2F3C7}" type="datetimeFigureOut">
               <a:rPr lang="en-GB" smtClean="0"/>
-              <a:t>16/02/2026</a:t>
+              <a:t>09/03/2026</a:t>
             </a:fld>
             <a:endParaRPr lang="en-GB"/>
           </a:p>
@@ -929,7 +945,7 @@
           <a:p>
             <a:fld id="{A18D3707-5733-4B01-BC83-BABD02B2F3C7}" type="datetimeFigureOut">
               <a:rPr lang="en-GB" smtClean="0"/>
-              <a:t>16/02/2026</a:t>
+              <a:t>09/03/2026</a:t>
             </a:fld>
             <a:endParaRPr lang="en-GB"/>
           </a:p>
@@ -1109,7 +1125,7 @@
           <a:p>
             <a:fld id="{A18D3707-5733-4B01-BC83-BABD02B2F3C7}" type="datetimeFigureOut">
               <a:rPr lang="en-GB" smtClean="0"/>
-              <a:t>16/02/2026</a:t>
+              <a:t>09/03/2026</a:t>
             </a:fld>
             <a:endParaRPr lang="en-GB"/>
           </a:p>
@@ -1279,7 +1295,7 @@
           <a:p>
             <a:fld id="{A18D3707-5733-4B01-BC83-BABD02B2F3C7}" type="datetimeFigureOut">
               <a:rPr lang="en-GB" smtClean="0"/>
-              <a:t>16/02/2026</a:t>
+              <a:t>09/03/2026</a:t>
             </a:fld>
             <a:endParaRPr lang="en-GB"/>
           </a:p>
@@ -1525,7 +1541,7 @@
           <a:p>
             <a:fld id="{A18D3707-5733-4B01-BC83-BABD02B2F3C7}" type="datetimeFigureOut">
               <a:rPr lang="en-GB" smtClean="0"/>
-              <a:t>16/02/2026</a:t>
+              <a:t>09/03/2026</a:t>
             </a:fld>
             <a:endParaRPr lang="en-GB"/>
           </a:p>
@@ -1757,7 +1773,7 @@
           <a:p>
             <a:fld id="{A18D3707-5733-4B01-BC83-BABD02B2F3C7}" type="datetimeFigureOut">
               <a:rPr lang="en-GB" smtClean="0"/>
-              <a:t>16/02/2026</a:t>
+              <a:t>09/03/2026</a:t>
             </a:fld>
             <a:endParaRPr lang="en-GB"/>
           </a:p>
@@ -2124,7 +2140,7 @@
           <a:p>
             <a:fld id="{A18D3707-5733-4B01-BC83-BABD02B2F3C7}" type="datetimeFigureOut">
               <a:rPr lang="en-GB" smtClean="0"/>
-              <a:t>16/02/2026</a:t>
+              <a:t>09/03/2026</a:t>
             </a:fld>
             <a:endParaRPr lang="en-GB"/>
           </a:p>
@@ -2242,7 +2258,7 @@
           <a:p>
             <a:fld id="{A18D3707-5733-4B01-BC83-BABD02B2F3C7}" type="datetimeFigureOut">
               <a:rPr lang="en-GB" smtClean="0"/>
-              <a:t>16/02/2026</a:t>
+              <a:t>09/03/2026</a:t>
             </a:fld>
             <a:endParaRPr lang="en-GB"/>
           </a:p>
@@ -2337,7 +2353,7 @@
           <a:p>
             <a:fld id="{A18D3707-5733-4B01-BC83-BABD02B2F3C7}" type="datetimeFigureOut">
               <a:rPr lang="en-GB" smtClean="0"/>
-              <a:t>16/02/2026</a:t>
+              <a:t>09/03/2026</a:t>
             </a:fld>
             <a:endParaRPr lang="en-GB"/>
           </a:p>
@@ -2614,7 +2630,7 @@
           <a:p>
             <a:fld id="{A18D3707-5733-4B01-BC83-BABD02B2F3C7}" type="datetimeFigureOut">
               <a:rPr lang="en-GB" smtClean="0"/>
-              <a:t>16/02/2026</a:t>
+              <a:t>09/03/2026</a:t>
             </a:fld>
             <a:endParaRPr lang="en-GB"/>
           </a:p>
@@ -2871,7 +2887,7 @@
           <a:p>
             <a:fld id="{A18D3707-5733-4B01-BC83-BABD02B2F3C7}" type="datetimeFigureOut">
               <a:rPr lang="en-GB" smtClean="0"/>
-              <a:t>16/02/2026</a:t>
+              <a:t>09/03/2026</a:t>
             </a:fld>
             <a:endParaRPr lang="en-GB"/>
           </a:p>
@@ -3084,7 +3100,7 @@
           <a:p>
             <a:fld id="{A18D3707-5733-4B01-BC83-BABD02B2F3C7}" type="datetimeFigureOut">
               <a:rPr lang="en-GB" smtClean="0"/>
-              <a:t>16/02/2026</a:t>
+              <a:t>09/03/2026</a:t>
             </a:fld>
             <a:endParaRPr lang="en-GB"/>
           </a:p>
@@ -17637,8 +17653,8 @@
         </p:nvSpPr>
         <p:spPr>
           <a:xfrm>
-            <a:off x="198269" y="2406831"/>
-            <a:ext cx="475200" cy="138499"/>
+            <a:off x="198268" y="2406831"/>
+            <a:ext cx="566113" cy="138499"/>
           </a:xfrm>
           <a:prstGeom prst="rect">
             <a:avLst/>
@@ -17659,7 +17675,7 @@
                 </a:solidFill>
                 <a:latin typeface="LM Roman 9" panose="00000500000000000000" pitchFamily="50" charset="0"/>
               </a:rPr>
-              <a:t>Healthcare</a:t>
+              <a:t> Hospital Capacity</a:t>
             </a:r>
           </a:p>
         </p:txBody>
@@ -19681,7 +19697,7 @@
                 </a:solidFill>
                 <a:latin typeface="LM Roman 9" panose="00000500000000000000" pitchFamily="50" charset="0"/>
               </a:rPr>
-              <a:t>Surveillance</a:t>
+              <a:t>   Case Isolation</a:t>
             </a:r>
           </a:p>
         </p:txBody>
@@ -20217,7 +20233,7 @@
                 </a:solidFill>
                 <a:latin typeface="LM Roman 9" panose="00000500000000000000" pitchFamily="50" charset="0"/>
               </a:rPr>
-              <a:t>Infection Ascertainment Ratio</a:t>
+              <a:t>Maximum Infection Ascertainment Ratio</a:t>
             </a:r>
           </a:p>
         </p:txBody>
@@ -20261,7 +20277,7 @@
                 </a:solidFill>
                 <a:latin typeface="LM Roman 9" panose="00000500000000000000" pitchFamily="50" charset="0"/>
               </a:rPr>
-              <a:t>Spare Hospital Capacity</a:t>
+              <a:t>Spare Hospital Beds</a:t>
             </a:r>
           </a:p>
         </p:txBody>

</xml_diff>

<commit_message>
Modified fig 1 Rt for elim
</commit_message>
<xml_diff>
--- a/plotting/figure_1.pptx
+++ b/plotting/figure_1.pptx
@@ -120,16 +120,24 @@
   <pc:docChgLst>
     <pc:chgData name="Doohan, Patrick E" userId="63cc5302-4d40-40c1-9c03-9c409d34e94b" providerId="ADAL" clId="{70E87B4F-4617-4322-AE14-14ADB5415D44}"/>
     <pc:docChg chg="undo custSel modSld">
-      <pc:chgData name="Doohan, Patrick E" userId="63cc5302-4d40-40c1-9c03-9c409d34e94b" providerId="ADAL" clId="{70E87B4F-4617-4322-AE14-14ADB5415D44}" dt="2026-03-09T11:54:36.383" v="655" actId="20577"/>
+      <pc:chgData name="Doohan, Patrick E" userId="63cc5302-4d40-40c1-9c03-9c409d34e94b" providerId="ADAL" clId="{70E87B4F-4617-4322-AE14-14ADB5415D44}" dt="2026-03-17T17:20:54.535" v="697" actId="1036"/>
       <pc:docMkLst>
         <pc:docMk/>
       </pc:docMkLst>
       <pc:sldChg chg="addSp modSp mod">
-        <pc:chgData name="Doohan, Patrick E" userId="63cc5302-4d40-40c1-9c03-9c409d34e94b" providerId="ADAL" clId="{70E87B4F-4617-4322-AE14-14ADB5415D44}" dt="2026-03-09T11:54:36.383" v="655" actId="20577"/>
+        <pc:chgData name="Doohan, Patrick E" userId="63cc5302-4d40-40c1-9c03-9c409d34e94b" providerId="ADAL" clId="{70E87B4F-4617-4322-AE14-14ADB5415D44}" dt="2026-03-17T17:20:54.535" v="697" actId="1036"/>
         <pc:sldMkLst>
           <pc:docMk/>
           <pc:sldMk cId="2445895467" sldId="256"/>
         </pc:sldMkLst>
+        <pc:spChg chg="mod">
+          <ac:chgData name="Doohan, Patrick E" userId="63cc5302-4d40-40c1-9c03-9c409d34e94b" providerId="ADAL" clId="{70E87B4F-4617-4322-AE14-14ADB5415D44}" dt="2026-03-17T17:20:54.535" v="697" actId="1036"/>
+          <ac:spMkLst>
+            <pc:docMk/>
+            <pc:sldMk cId="2445895467" sldId="256"/>
+            <ac:spMk id="35" creationId="{7FA434D0-CEC8-25A8-E5A1-8A2F0A306937}"/>
+          </ac:spMkLst>
+        </pc:spChg>
         <pc:spChg chg="mod">
           <ac:chgData name="Doohan, Patrick E" userId="63cc5302-4d40-40c1-9c03-9c409d34e94b" providerId="ADAL" clId="{70E87B4F-4617-4322-AE14-14ADB5415D44}" dt="2026-03-09T11:50:45.164" v="609" actId="20577"/>
           <ac:spMkLst>
@@ -266,7 +274,7 @@
           <a:p>
             <a:fld id="{B537B997-3BAF-428A-BD7E-EF61D113E801}" type="datetimeFigureOut">
               <a:rPr lang="en-GB" smtClean="0"/>
-              <a:t>09/03/2026</a:t>
+              <a:t>17/03/2026</a:t>
             </a:fld>
             <a:endParaRPr lang="en-GB"/>
           </a:p>
@@ -775,7 +783,7 @@
           <a:p>
             <a:fld id="{A18D3707-5733-4B01-BC83-BABD02B2F3C7}" type="datetimeFigureOut">
               <a:rPr lang="en-GB" smtClean="0"/>
-              <a:t>09/03/2026</a:t>
+              <a:t>17/03/2026</a:t>
             </a:fld>
             <a:endParaRPr lang="en-GB"/>
           </a:p>
@@ -945,7 +953,7 @@
           <a:p>
             <a:fld id="{A18D3707-5733-4B01-BC83-BABD02B2F3C7}" type="datetimeFigureOut">
               <a:rPr lang="en-GB" smtClean="0"/>
-              <a:t>09/03/2026</a:t>
+              <a:t>17/03/2026</a:t>
             </a:fld>
             <a:endParaRPr lang="en-GB"/>
           </a:p>
@@ -1125,7 +1133,7 @@
           <a:p>
             <a:fld id="{A18D3707-5733-4B01-BC83-BABD02B2F3C7}" type="datetimeFigureOut">
               <a:rPr lang="en-GB" smtClean="0"/>
-              <a:t>09/03/2026</a:t>
+              <a:t>17/03/2026</a:t>
             </a:fld>
             <a:endParaRPr lang="en-GB"/>
           </a:p>
@@ -1295,7 +1303,7 @@
           <a:p>
             <a:fld id="{A18D3707-5733-4B01-BC83-BABD02B2F3C7}" type="datetimeFigureOut">
               <a:rPr lang="en-GB" smtClean="0"/>
-              <a:t>09/03/2026</a:t>
+              <a:t>17/03/2026</a:t>
             </a:fld>
             <a:endParaRPr lang="en-GB"/>
           </a:p>
@@ -1541,7 +1549,7 @@
           <a:p>
             <a:fld id="{A18D3707-5733-4B01-BC83-BABD02B2F3C7}" type="datetimeFigureOut">
               <a:rPr lang="en-GB" smtClean="0"/>
-              <a:t>09/03/2026</a:t>
+              <a:t>17/03/2026</a:t>
             </a:fld>
             <a:endParaRPr lang="en-GB"/>
           </a:p>
@@ -1773,7 +1781,7 @@
           <a:p>
             <a:fld id="{A18D3707-5733-4B01-BC83-BABD02B2F3C7}" type="datetimeFigureOut">
               <a:rPr lang="en-GB" smtClean="0"/>
-              <a:t>09/03/2026</a:t>
+              <a:t>17/03/2026</a:t>
             </a:fld>
             <a:endParaRPr lang="en-GB"/>
           </a:p>
@@ -2140,7 +2148,7 @@
           <a:p>
             <a:fld id="{A18D3707-5733-4B01-BC83-BABD02B2F3C7}" type="datetimeFigureOut">
               <a:rPr lang="en-GB" smtClean="0"/>
-              <a:t>09/03/2026</a:t>
+              <a:t>17/03/2026</a:t>
             </a:fld>
             <a:endParaRPr lang="en-GB"/>
           </a:p>
@@ -2258,7 +2266,7 @@
           <a:p>
             <a:fld id="{A18D3707-5733-4B01-BC83-BABD02B2F3C7}" type="datetimeFigureOut">
               <a:rPr lang="en-GB" smtClean="0"/>
-              <a:t>09/03/2026</a:t>
+              <a:t>17/03/2026</a:t>
             </a:fld>
             <a:endParaRPr lang="en-GB"/>
           </a:p>
@@ -2353,7 +2361,7 @@
           <a:p>
             <a:fld id="{A18D3707-5733-4B01-BC83-BABD02B2F3C7}" type="datetimeFigureOut">
               <a:rPr lang="en-GB" smtClean="0"/>
-              <a:t>09/03/2026</a:t>
+              <a:t>17/03/2026</a:t>
             </a:fld>
             <a:endParaRPr lang="en-GB"/>
           </a:p>
@@ -2630,7 +2638,7 @@
           <a:p>
             <a:fld id="{A18D3707-5733-4B01-BC83-BABD02B2F3C7}" type="datetimeFigureOut">
               <a:rPr lang="en-GB" smtClean="0"/>
-              <a:t>09/03/2026</a:t>
+              <a:t>17/03/2026</a:t>
             </a:fld>
             <a:endParaRPr lang="en-GB"/>
           </a:p>
@@ -2887,7 +2895,7 @@
           <a:p>
             <a:fld id="{A18D3707-5733-4B01-BC83-BABD02B2F3C7}" type="datetimeFigureOut">
               <a:rPr lang="en-GB" smtClean="0"/>
-              <a:t>09/03/2026</a:t>
+              <a:t>17/03/2026</a:t>
             </a:fld>
             <a:endParaRPr lang="en-GB"/>
           </a:p>
@@ -3100,7 +3108,7 @@
           <a:p>
             <a:fld id="{A18D3707-5733-4B01-BC83-BABD02B2F3C7}" type="datetimeFigureOut">
               <a:rPr lang="en-GB" smtClean="0"/>
-              <a:t>09/03/2026</a:t>
+              <a:t>17/03/2026</a:t>
             </a:fld>
             <a:endParaRPr lang="en-GB"/>
           </a:p>
@@ -17738,8 +17746,8 @@
         </p:nvSpPr>
         <p:spPr>
           <a:xfrm>
-            <a:off x="3102589" y="3430099"/>
-            <a:ext cx="397115" cy="138499"/>
+            <a:off x="3045619" y="3422956"/>
+            <a:ext cx="512175" cy="184666"/>
           </a:xfrm>
           <a:prstGeom prst="rect">
             <a:avLst/>
@@ -17769,7 +17777,7 @@
               <a:rPr lang="en-GB" sz="300" dirty="0">
                 <a:latin typeface="LM Roman 9" panose="00000500000000000000" pitchFamily="50" charset="0"/>
               </a:rPr>
-              <a:t> &lt; 1?</a:t>
+              <a:t>(Light Closures) &lt; 1?</a:t>
             </a:r>
           </a:p>
         </p:txBody>

</xml_diff>

<commit_message>
pulled hospital occupancy threshold from simulation data amended figure 5 to plot
</commit_message>
<xml_diff>
--- a/plotting/figure_1.pptx
+++ b/plotting/figure_1.pptx
@@ -115,77 +115,45 @@
 </p:presentation>
 </file>
 
+<file path=ppt/revisionInfo.xml><?xml version="1.0" encoding="utf-8"?>
+<p1510:revInfo xmlns:a="http://schemas.openxmlformats.org/drawingml/2006/main" xmlns:r="http://schemas.openxmlformats.org/officeDocument/2006/relationships" xmlns:p1510="http://schemas.microsoft.com/office/powerpoint/2015/10/main">
+  <p1510:revLst>
+    <p1510:client id="{FABB6BE3-6290-4985-9354-71C22ABBEFC2}" v="1" dt="2026-06-08T15:58:34.897"/>
+  </p1510:revLst>
+</p1510:revInfo>
+</file>
+
 <file path=ppt/changesInfos/changesInfo1.xml><?xml version="1.0" encoding="utf-8"?>
 <pc:chgInfo xmlns:a="http://schemas.openxmlformats.org/drawingml/2006/main" xmlns:r="http://schemas.openxmlformats.org/officeDocument/2006/relationships" xmlns:ac="http://schemas.microsoft.com/office/drawing/2013/main/command" xmlns:pc="http://schemas.microsoft.com/office/powerpoint/2013/main/command">
   <pc:docChgLst>
     <pc:chgData name="Doohan, Patrick E" userId="63cc5302-4d40-40c1-9c03-9c409d34e94b" providerId="ADAL" clId="{70E87B4F-4617-4322-AE14-14ADB5415D44}"/>
     <pc:docChg chg="undo custSel modSld">
-      <pc:chgData name="Doohan, Patrick E" userId="63cc5302-4d40-40c1-9c03-9c409d34e94b" providerId="ADAL" clId="{70E87B4F-4617-4322-AE14-14ADB5415D44}" dt="2026-03-17T17:20:54.535" v="697" actId="1036"/>
+      <pc:chgData name="Doohan, Patrick E" userId="63cc5302-4d40-40c1-9c03-9c409d34e94b" providerId="ADAL" clId="{70E87B4F-4617-4322-AE14-14ADB5415D44}" dt="2026-06-08T15:58:34.897" v="717"/>
       <pc:docMkLst>
         <pc:docMk/>
       </pc:docMkLst>
       <pc:sldChg chg="addSp modSp mod">
-        <pc:chgData name="Doohan, Patrick E" userId="63cc5302-4d40-40c1-9c03-9c409d34e94b" providerId="ADAL" clId="{70E87B4F-4617-4322-AE14-14ADB5415D44}" dt="2026-03-17T17:20:54.535" v="697" actId="1036"/>
+        <pc:chgData name="Doohan, Patrick E" userId="63cc5302-4d40-40c1-9c03-9c409d34e94b" providerId="ADAL" clId="{70E87B4F-4617-4322-AE14-14ADB5415D44}" dt="2026-06-08T15:58:34.897" v="717"/>
         <pc:sldMkLst>
           <pc:docMk/>
           <pc:sldMk cId="2445895467" sldId="256"/>
         </pc:sldMkLst>
         <pc:spChg chg="mod">
-          <ac:chgData name="Doohan, Patrick E" userId="63cc5302-4d40-40c1-9c03-9c409d34e94b" providerId="ADAL" clId="{70E87B4F-4617-4322-AE14-14ADB5415D44}" dt="2026-03-17T17:20:54.535" v="697" actId="1036"/>
+          <ac:chgData name="Doohan, Patrick E" userId="63cc5302-4d40-40c1-9c03-9c409d34e94b" providerId="ADAL" clId="{70E87B4F-4617-4322-AE14-14ADB5415D44}" dt="2026-06-08T15:58:34.897" v="717"/>
           <ac:spMkLst>
             <pc:docMk/>
             <pc:sldMk cId="2445895467" sldId="256"/>
-            <ac:spMk id="35" creationId="{7FA434D0-CEC8-25A8-E5A1-8A2F0A306937}"/>
+            <ac:spMk id="40" creationId="{1E408D13-A12D-1306-58E4-E965A5B1B6C5}"/>
           </ac:spMkLst>
         </pc:spChg>
         <pc:spChg chg="mod">
-          <ac:chgData name="Doohan, Patrick E" userId="63cc5302-4d40-40c1-9c03-9c409d34e94b" providerId="ADAL" clId="{70E87B4F-4617-4322-AE14-14ADB5415D44}" dt="2026-03-09T11:50:45.164" v="609" actId="20577"/>
+          <ac:chgData name="Doohan, Patrick E" userId="63cc5302-4d40-40c1-9c03-9c409d34e94b" providerId="ADAL" clId="{70E87B4F-4617-4322-AE14-14ADB5415D44}" dt="2026-06-08T15:58:23.044" v="716" actId="6549"/>
           <ac:spMkLst>
             <pc:docMk/>
             <pc:sldMk cId="2445895467" sldId="256"/>
-            <ac:spMk id="467" creationId="{1346ACAB-2B5A-ABDB-D5D7-14648162A454}"/>
+            <ac:spMk id="45" creationId="{AAE4B147-D2E0-8DE2-2BCD-C8CE50EF6C1F}"/>
           </ac:spMkLst>
         </pc:spChg>
-        <pc:spChg chg="mod">
-          <ac:chgData name="Doohan, Patrick E" userId="63cc5302-4d40-40c1-9c03-9c409d34e94b" providerId="ADAL" clId="{70E87B4F-4617-4322-AE14-14ADB5415D44}" dt="2026-03-09T11:54:36.383" v="655" actId="20577"/>
-          <ac:spMkLst>
-            <pc:docMk/>
-            <pc:sldMk cId="2445895467" sldId="256"/>
-            <ac:spMk id="475" creationId="{7AC2AB27-7DB3-AA07-DD70-706261CFD5F3}"/>
-          </ac:spMkLst>
-        </pc:spChg>
-        <pc:spChg chg="mod">
-          <ac:chgData name="Doohan, Patrick E" userId="63cc5302-4d40-40c1-9c03-9c409d34e94b" providerId="ADAL" clId="{70E87B4F-4617-4322-AE14-14ADB5415D44}" dt="2026-03-09T11:51:31.843" v="637" actId="20577"/>
-          <ac:spMkLst>
-            <pc:docMk/>
-            <pc:sldMk cId="2445895467" sldId="256"/>
-            <ac:spMk id="480" creationId="{181AE0F6-8AA1-1348-A5FE-5521603C13E1}"/>
-          </ac:spMkLst>
-        </pc:spChg>
-        <pc:spChg chg="mod">
-          <ac:chgData name="Doohan, Patrick E" userId="63cc5302-4d40-40c1-9c03-9c409d34e94b" providerId="ADAL" clId="{70E87B4F-4617-4322-AE14-14ADB5415D44}" dt="2026-03-09T11:51:37.438" v="641" actId="20577"/>
-          <ac:spMkLst>
-            <pc:docMk/>
-            <pc:sldMk cId="2445895467" sldId="256"/>
-            <ac:spMk id="486" creationId="{3B4706F9-3A32-BB9C-8193-7A22108E5AD6}"/>
-          </ac:spMkLst>
-        </pc:spChg>
-        <pc:picChg chg="mod">
-          <ac:chgData name="Doohan, Patrick E" userId="63cc5302-4d40-40c1-9c03-9c409d34e94b" providerId="ADAL" clId="{70E87B4F-4617-4322-AE14-14ADB5415D44}" dt="2026-02-16T15:28:47.685" v="531" actId="14826"/>
-          <ac:picMkLst>
-            <pc:docMk/>
-            <pc:sldMk cId="2445895467" sldId="256"/>
-            <ac:picMk id="2" creationId="{FFC319A7-1BF8-22ED-15C2-A3795F551BA2}"/>
-          </ac:picMkLst>
-        </pc:picChg>
-        <pc:picChg chg="mod">
-          <ac:chgData name="Doohan, Patrick E" userId="63cc5302-4d40-40c1-9c03-9c409d34e94b" providerId="ADAL" clId="{70E87B4F-4617-4322-AE14-14ADB5415D44}" dt="2026-02-16T15:27:51.959" v="524" actId="14826"/>
-          <ac:picMkLst>
-            <pc:docMk/>
-            <pc:sldMk cId="2445895467" sldId="256"/>
-            <ac:picMk id="17" creationId="{8675D29F-9856-1B61-3A0B-0274C10E079D}"/>
-          </ac:picMkLst>
-        </pc:picChg>
       </pc:sldChg>
     </pc:docChg>
   </pc:docChgLst>
@@ -274,7 +242,7 @@
           <a:p>
             <a:fld id="{B537B997-3BAF-428A-BD7E-EF61D113E801}" type="datetimeFigureOut">
               <a:rPr lang="en-GB" smtClean="0"/>
-              <a:t>17/03/2026</a:t>
+              <a:t>08/06/2026</a:t>
             </a:fld>
             <a:endParaRPr lang="en-GB"/>
           </a:p>
@@ -783,7 +751,7 @@
           <a:p>
             <a:fld id="{A18D3707-5733-4B01-BC83-BABD02B2F3C7}" type="datetimeFigureOut">
               <a:rPr lang="en-GB" smtClean="0"/>
-              <a:t>17/03/2026</a:t>
+              <a:t>08/06/2026</a:t>
             </a:fld>
             <a:endParaRPr lang="en-GB"/>
           </a:p>
@@ -953,7 +921,7 @@
           <a:p>
             <a:fld id="{A18D3707-5733-4B01-BC83-BABD02B2F3C7}" type="datetimeFigureOut">
               <a:rPr lang="en-GB" smtClean="0"/>
-              <a:t>17/03/2026</a:t>
+              <a:t>08/06/2026</a:t>
             </a:fld>
             <a:endParaRPr lang="en-GB"/>
           </a:p>
@@ -1133,7 +1101,7 @@
           <a:p>
             <a:fld id="{A18D3707-5733-4B01-BC83-BABD02B2F3C7}" type="datetimeFigureOut">
               <a:rPr lang="en-GB" smtClean="0"/>
-              <a:t>17/03/2026</a:t>
+              <a:t>08/06/2026</a:t>
             </a:fld>
             <a:endParaRPr lang="en-GB"/>
           </a:p>
@@ -1303,7 +1271,7 @@
           <a:p>
             <a:fld id="{A18D3707-5733-4B01-BC83-BABD02B2F3C7}" type="datetimeFigureOut">
               <a:rPr lang="en-GB" smtClean="0"/>
-              <a:t>17/03/2026</a:t>
+              <a:t>08/06/2026</a:t>
             </a:fld>
             <a:endParaRPr lang="en-GB"/>
           </a:p>
@@ -1549,7 +1517,7 @@
           <a:p>
             <a:fld id="{A18D3707-5733-4B01-BC83-BABD02B2F3C7}" type="datetimeFigureOut">
               <a:rPr lang="en-GB" smtClean="0"/>
-              <a:t>17/03/2026</a:t>
+              <a:t>08/06/2026</a:t>
             </a:fld>
             <a:endParaRPr lang="en-GB"/>
           </a:p>
@@ -1781,7 +1749,7 @@
           <a:p>
             <a:fld id="{A18D3707-5733-4B01-BC83-BABD02B2F3C7}" type="datetimeFigureOut">
               <a:rPr lang="en-GB" smtClean="0"/>
-              <a:t>17/03/2026</a:t>
+              <a:t>08/06/2026</a:t>
             </a:fld>
             <a:endParaRPr lang="en-GB"/>
           </a:p>
@@ -2148,7 +2116,7 @@
           <a:p>
             <a:fld id="{A18D3707-5733-4B01-BC83-BABD02B2F3C7}" type="datetimeFigureOut">
               <a:rPr lang="en-GB" smtClean="0"/>
-              <a:t>17/03/2026</a:t>
+              <a:t>08/06/2026</a:t>
             </a:fld>
             <a:endParaRPr lang="en-GB"/>
           </a:p>
@@ -2266,7 +2234,7 @@
           <a:p>
             <a:fld id="{A18D3707-5733-4B01-BC83-BABD02B2F3C7}" type="datetimeFigureOut">
               <a:rPr lang="en-GB" smtClean="0"/>
-              <a:t>17/03/2026</a:t>
+              <a:t>08/06/2026</a:t>
             </a:fld>
             <a:endParaRPr lang="en-GB"/>
           </a:p>
@@ -2361,7 +2329,7 @@
           <a:p>
             <a:fld id="{A18D3707-5733-4B01-BC83-BABD02B2F3C7}" type="datetimeFigureOut">
               <a:rPr lang="en-GB" smtClean="0"/>
-              <a:t>17/03/2026</a:t>
+              <a:t>08/06/2026</a:t>
             </a:fld>
             <a:endParaRPr lang="en-GB"/>
           </a:p>
@@ -2638,7 +2606,7 @@
           <a:p>
             <a:fld id="{A18D3707-5733-4B01-BC83-BABD02B2F3C7}" type="datetimeFigureOut">
               <a:rPr lang="en-GB" smtClean="0"/>
-              <a:t>17/03/2026</a:t>
+              <a:t>08/06/2026</a:t>
             </a:fld>
             <a:endParaRPr lang="en-GB"/>
           </a:p>
@@ -2895,7 +2863,7 @@
           <a:p>
             <a:fld id="{A18D3707-5733-4B01-BC83-BABD02B2F3C7}" type="datetimeFigureOut">
               <a:rPr lang="en-GB" smtClean="0"/>
-              <a:t>17/03/2026</a:t>
+              <a:t>08/06/2026</a:t>
             </a:fld>
             <a:endParaRPr lang="en-GB"/>
           </a:p>
@@ -3108,7 +3076,7 @@
           <a:p>
             <a:fld id="{A18D3707-5733-4B01-BC83-BABD02B2F3C7}" type="datetimeFigureOut">
               <a:rPr lang="en-GB" smtClean="0"/>
-              <a:t>17/03/2026</a:t>
+              <a:t>08/06/2026</a:t>
             </a:fld>
             <a:endParaRPr lang="en-GB"/>
           </a:p>
@@ -9104,10 +9072,10 @@
           <p:nvPr/>
         </p:nvPicPr>
         <p:blipFill>
-          <a:blip r:embed="rId3">
+          <a:blip>
             <a:extLst>
               <a:ext uri="{96DAC541-7B7A-43D3-8B79-37D633B846F1}">
-                <asvg:svgBlip xmlns:asvg="http://schemas.microsoft.com/office/drawing/2016/SVG/main" r:embed="rId4"/>
+                <asvg:svgBlip xmlns:asvg="http://schemas.microsoft.com/office/drawing/2016/SVG/main" r:embed="rId3"/>
               </a:ext>
             </a:extLst>
           </a:blip>
@@ -9140,10 +9108,10 @@
           <p:nvPr/>
         </p:nvPicPr>
         <p:blipFill>
-          <a:blip r:embed="rId5">
+          <a:blip>
             <a:extLst>
               <a:ext uri="{96DAC541-7B7A-43D3-8B79-37D633B846F1}">
-                <asvg:svgBlip xmlns:asvg="http://schemas.microsoft.com/office/drawing/2016/SVG/main" r:embed="rId6"/>
+                <asvg:svgBlip xmlns:asvg="http://schemas.microsoft.com/office/drawing/2016/SVG/main" r:embed="rId4"/>
               </a:ext>
             </a:extLst>
           </a:blip>
@@ -9176,10 +9144,10 @@
           <p:nvPr/>
         </p:nvPicPr>
         <p:blipFill>
-          <a:blip r:embed="rId7">
+          <a:blip>
             <a:extLst>
               <a:ext uri="{96DAC541-7B7A-43D3-8B79-37D633B846F1}">
-                <asvg:svgBlip xmlns:asvg="http://schemas.microsoft.com/office/drawing/2016/SVG/main" r:embed="rId8"/>
+                <asvg:svgBlip xmlns:asvg="http://schemas.microsoft.com/office/drawing/2016/SVG/main" r:embed="rId5"/>
               </a:ext>
             </a:extLst>
           </a:blip>
@@ -9212,10 +9180,10 @@
           <p:nvPr/>
         </p:nvPicPr>
         <p:blipFill>
-          <a:blip r:embed="rId9">
+          <a:blip>
             <a:extLst>
               <a:ext uri="{96DAC541-7B7A-43D3-8B79-37D633B846F1}">
-                <asvg:svgBlip xmlns:asvg="http://schemas.microsoft.com/office/drawing/2016/SVG/main" r:embed="rId10"/>
+                <asvg:svgBlip xmlns:asvg="http://schemas.microsoft.com/office/drawing/2016/SVG/main" r:embed="rId6"/>
               </a:ext>
             </a:extLst>
           </a:blip>
@@ -9248,10 +9216,10 @@
           <p:nvPr/>
         </p:nvPicPr>
         <p:blipFill>
-          <a:blip r:embed="rId11">
+          <a:blip>
             <a:extLst>
               <a:ext uri="{96DAC541-7B7A-43D3-8B79-37D633B846F1}">
-                <asvg:svgBlip xmlns:asvg="http://schemas.microsoft.com/office/drawing/2016/SVG/main" r:embed="rId12"/>
+                <asvg:svgBlip xmlns:asvg="http://schemas.microsoft.com/office/drawing/2016/SVG/main" r:embed="rId7"/>
               </a:ext>
             </a:extLst>
           </a:blip>
@@ -9284,10 +9252,10 @@
           <p:nvPr/>
         </p:nvPicPr>
         <p:blipFill>
-          <a:blip r:embed="rId13">
+          <a:blip>
             <a:extLst>
               <a:ext uri="{96DAC541-7B7A-43D3-8B79-37D633B846F1}">
-                <asvg:svgBlip xmlns:asvg="http://schemas.microsoft.com/office/drawing/2016/SVG/main" r:embed="rId14"/>
+                <asvg:svgBlip xmlns:asvg="http://schemas.microsoft.com/office/drawing/2016/SVG/main" r:embed="rId8"/>
               </a:ext>
             </a:extLst>
           </a:blip>
@@ -9392,7 +9360,7 @@
             <p:nvPr/>
           </p:nvPicPr>
           <p:blipFill>
-            <a:blip r:embed="rId15"/>
+            <a:blip r:embed="rId9"/>
             <a:stretch>
               <a:fillRect/>
             </a:stretch>
@@ -9536,7 +9504,7 @@
             <p:nvPr/>
           </p:nvPicPr>
           <p:blipFill>
-            <a:blip r:embed="rId15"/>
+            <a:blip r:embed="rId9"/>
             <a:stretch>
               <a:fillRect/>
             </a:stretch>
@@ -9680,7 +9648,7 @@
             <p:nvPr/>
           </p:nvPicPr>
           <p:blipFill>
-            <a:blip r:embed="rId15"/>
+            <a:blip r:embed="rId9"/>
             <a:stretch>
               <a:fillRect/>
             </a:stretch>
@@ -9824,7 +9792,7 @@
             <p:nvPr/>
           </p:nvPicPr>
           <p:blipFill>
-            <a:blip r:embed="rId15"/>
+            <a:blip r:embed="rId9"/>
             <a:stretch>
               <a:fillRect/>
             </a:stretch>
@@ -10553,10 +10521,10 @@
             <p:nvPr/>
           </p:nvPicPr>
           <p:blipFill>
-            <a:blip r:embed="rId16">
+            <a:blip>
               <a:extLst>
                 <a:ext uri="{96DAC541-7B7A-43D3-8B79-37D633B846F1}">
-                  <asvg:svgBlip xmlns:asvg="http://schemas.microsoft.com/office/drawing/2016/SVG/main" r:embed="rId17"/>
+                  <asvg:svgBlip xmlns:asvg="http://schemas.microsoft.com/office/drawing/2016/SVG/main" r:embed="rId10"/>
                 </a:ext>
               </a:extLst>
             </a:blip>
@@ -10589,10 +10557,10 @@
             <p:nvPr/>
           </p:nvPicPr>
           <p:blipFill>
-            <a:blip r:embed="rId18">
+            <a:blip>
               <a:extLst>
                 <a:ext uri="{96DAC541-7B7A-43D3-8B79-37D633B846F1}">
-                  <asvg:svgBlip xmlns:asvg="http://schemas.microsoft.com/office/drawing/2016/SVG/main" r:embed="rId19"/>
+                  <asvg:svgBlip xmlns:asvg="http://schemas.microsoft.com/office/drawing/2016/SVG/main" r:embed="rId11"/>
                 </a:ext>
               </a:extLst>
             </a:blip>
@@ -10666,10 +10634,10 @@
               <p:nvPr/>
             </p:nvPicPr>
             <p:blipFill>
-              <a:blip r:embed="rId16">
+              <a:blip>
                 <a:extLst>
                   <a:ext uri="{96DAC541-7B7A-43D3-8B79-37D633B846F1}">
-                    <asvg:svgBlip xmlns:asvg="http://schemas.microsoft.com/office/drawing/2016/SVG/main" r:embed="rId17"/>
+                    <asvg:svgBlip xmlns:asvg="http://schemas.microsoft.com/office/drawing/2016/SVG/main" r:embed="rId10"/>
                   </a:ext>
                 </a:extLst>
               </a:blip>
@@ -10702,10 +10670,10 @@
               <p:nvPr/>
             </p:nvPicPr>
             <p:blipFill>
-              <a:blip r:embed="rId18">
+              <a:blip>
                 <a:extLst>
                   <a:ext uri="{96DAC541-7B7A-43D3-8B79-37D633B846F1}">
-                    <asvg:svgBlip xmlns:asvg="http://schemas.microsoft.com/office/drawing/2016/SVG/main" r:embed="rId19"/>
+                    <asvg:svgBlip xmlns:asvg="http://schemas.microsoft.com/office/drawing/2016/SVG/main" r:embed="rId11"/>
                   </a:ext>
                 </a:extLst>
               </a:blip>
@@ -10814,10 +10782,10 @@
             <p:nvPr/>
           </p:nvPicPr>
           <p:blipFill>
-            <a:blip r:embed="rId16">
+            <a:blip>
               <a:extLst>
                 <a:ext uri="{96DAC541-7B7A-43D3-8B79-37D633B846F1}">
-                  <asvg:svgBlip xmlns:asvg="http://schemas.microsoft.com/office/drawing/2016/SVG/main" r:embed="rId17"/>
+                  <asvg:svgBlip xmlns:asvg="http://schemas.microsoft.com/office/drawing/2016/SVG/main" r:embed="rId10"/>
                 </a:ext>
               </a:extLst>
             </a:blip>
@@ -11167,10 +11135,10 @@
             <p:nvPr/>
           </p:nvPicPr>
           <p:blipFill>
-            <a:blip r:embed="rId16">
+            <a:blip>
               <a:extLst>
                 <a:ext uri="{96DAC541-7B7A-43D3-8B79-37D633B846F1}">
-                  <asvg:svgBlip xmlns:asvg="http://schemas.microsoft.com/office/drawing/2016/SVG/main" r:embed="rId17"/>
+                  <asvg:svgBlip xmlns:asvg="http://schemas.microsoft.com/office/drawing/2016/SVG/main" r:embed="rId10"/>
                 </a:ext>
               </a:extLst>
             </a:blip>
@@ -11203,10 +11171,10 @@
             <p:nvPr/>
           </p:nvPicPr>
           <p:blipFill>
-            <a:blip r:embed="rId18">
+            <a:blip>
               <a:extLst>
                 <a:ext uri="{96DAC541-7B7A-43D3-8B79-37D633B846F1}">
-                  <asvg:svgBlip xmlns:asvg="http://schemas.microsoft.com/office/drawing/2016/SVG/main" r:embed="rId19"/>
+                  <asvg:svgBlip xmlns:asvg="http://schemas.microsoft.com/office/drawing/2016/SVG/main" r:embed="rId11"/>
                 </a:ext>
               </a:extLst>
             </a:blip>
@@ -11260,10 +11228,10 @@
             <p:nvPr/>
           </p:nvPicPr>
           <p:blipFill>
-            <a:blip r:embed="rId16">
+            <a:blip>
               <a:extLst>
                 <a:ext uri="{96DAC541-7B7A-43D3-8B79-37D633B846F1}">
-                  <asvg:svgBlip xmlns:asvg="http://schemas.microsoft.com/office/drawing/2016/SVG/main" r:embed="rId17"/>
+                  <asvg:svgBlip xmlns:asvg="http://schemas.microsoft.com/office/drawing/2016/SVG/main" r:embed="rId10"/>
                 </a:ext>
               </a:extLst>
             </a:blip>
@@ -11296,10 +11264,10 @@
             <p:nvPr/>
           </p:nvPicPr>
           <p:blipFill>
-            <a:blip r:embed="rId18">
+            <a:blip>
               <a:extLst>
                 <a:ext uri="{96DAC541-7B7A-43D3-8B79-37D633B846F1}">
-                  <asvg:svgBlip xmlns:asvg="http://schemas.microsoft.com/office/drawing/2016/SVG/main" r:embed="rId19"/>
+                  <asvg:svgBlip xmlns:asvg="http://schemas.microsoft.com/office/drawing/2016/SVG/main" r:embed="rId11"/>
                 </a:ext>
               </a:extLst>
             </a:blip>
@@ -11333,10 +11301,10 @@
           <p:nvPr/>
         </p:nvPicPr>
         <p:blipFill>
-          <a:blip r:embed="rId16">
+          <a:blip>
             <a:extLst>
               <a:ext uri="{96DAC541-7B7A-43D3-8B79-37D633B846F1}">
-                <asvg:svgBlip xmlns:asvg="http://schemas.microsoft.com/office/drawing/2016/SVG/main" r:embed="rId17"/>
+                <asvg:svgBlip xmlns:asvg="http://schemas.microsoft.com/office/drawing/2016/SVG/main" r:embed="rId10"/>
               </a:ext>
             </a:extLst>
           </a:blip>
@@ -11389,10 +11357,10 @@
             <p:nvPr/>
           </p:nvPicPr>
           <p:blipFill>
-            <a:blip r:embed="rId16">
+            <a:blip>
               <a:extLst>
                 <a:ext uri="{96DAC541-7B7A-43D3-8B79-37D633B846F1}">
-                  <asvg:svgBlip xmlns:asvg="http://schemas.microsoft.com/office/drawing/2016/SVG/main" r:embed="rId17"/>
+                  <asvg:svgBlip xmlns:asvg="http://schemas.microsoft.com/office/drawing/2016/SVG/main" r:embed="rId10"/>
                 </a:ext>
               </a:extLst>
             </a:blip>
@@ -11425,10 +11393,10 @@
             <p:nvPr/>
           </p:nvPicPr>
           <p:blipFill>
-            <a:blip r:embed="rId18">
+            <a:blip>
               <a:extLst>
                 <a:ext uri="{96DAC541-7B7A-43D3-8B79-37D633B846F1}">
-                  <asvg:svgBlip xmlns:asvg="http://schemas.microsoft.com/office/drawing/2016/SVG/main" r:embed="rId19"/>
+                  <asvg:svgBlip xmlns:asvg="http://schemas.microsoft.com/office/drawing/2016/SVG/main" r:embed="rId11"/>
                 </a:ext>
               </a:extLst>
             </a:blip>
@@ -11780,10 +11748,10 @@
           <p:nvPr/>
         </p:nvPicPr>
         <p:blipFill>
-          <a:blip r:embed="rId20">
+          <a:blip>
             <a:extLst>
               <a:ext uri="{96DAC541-7B7A-43D3-8B79-37D633B846F1}">
-                <asvg:svgBlip xmlns:asvg="http://schemas.microsoft.com/office/drawing/2016/SVG/main" r:embed="rId21"/>
+                <asvg:svgBlip xmlns:asvg="http://schemas.microsoft.com/office/drawing/2016/SVG/main" r:embed="rId12"/>
               </a:ext>
             </a:extLst>
           </a:blip>
@@ -11836,10 +11804,10 @@
             <p:nvPr/>
           </p:nvPicPr>
           <p:blipFill>
-            <a:blip r:embed="rId16">
+            <a:blip>
               <a:extLst>
                 <a:ext uri="{96DAC541-7B7A-43D3-8B79-37D633B846F1}">
-                  <asvg:svgBlip xmlns:asvg="http://schemas.microsoft.com/office/drawing/2016/SVG/main" r:embed="rId17"/>
+                  <asvg:svgBlip xmlns:asvg="http://schemas.microsoft.com/office/drawing/2016/SVG/main" r:embed="rId10"/>
                 </a:ext>
               </a:extLst>
             </a:blip>
@@ -11872,10 +11840,10 @@
             <p:nvPr/>
           </p:nvPicPr>
           <p:blipFill>
-            <a:blip r:embed="rId18">
+            <a:blip>
               <a:extLst>
                 <a:ext uri="{96DAC541-7B7A-43D3-8B79-37D633B846F1}">
-                  <asvg:svgBlip xmlns:asvg="http://schemas.microsoft.com/office/drawing/2016/SVG/main" r:embed="rId19"/>
+                  <asvg:svgBlip xmlns:asvg="http://schemas.microsoft.com/office/drawing/2016/SVG/main" r:embed="rId11"/>
                 </a:ext>
               </a:extLst>
             </a:blip>
@@ -11909,10 +11877,10 @@
           <p:nvPr/>
         </p:nvPicPr>
         <p:blipFill>
-          <a:blip r:embed="rId18">
+          <a:blip>
             <a:extLst>
               <a:ext uri="{96DAC541-7B7A-43D3-8B79-37D633B846F1}">
-                <asvg:svgBlip xmlns:asvg="http://schemas.microsoft.com/office/drawing/2016/SVG/main" r:embed="rId19"/>
+                <asvg:svgBlip xmlns:asvg="http://schemas.microsoft.com/office/drawing/2016/SVG/main" r:embed="rId11"/>
               </a:ext>
             </a:extLst>
           </a:blip>
@@ -11965,10 +11933,10 @@
             <p:nvPr/>
           </p:nvPicPr>
           <p:blipFill>
-            <a:blip r:embed="rId16">
+            <a:blip>
               <a:extLst>
                 <a:ext uri="{96DAC541-7B7A-43D3-8B79-37D633B846F1}">
-                  <asvg:svgBlip xmlns:asvg="http://schemas.microsoft.com/office/drawing/2016/SVG/main" r:embed="rId17"/>
+                  <asvg:svgBlip xmlns:asvg="http://schemas.microsoft.com/office/drawing/2016/SVG/main" r:embed="rId10"/>
                 </a:ext>
               </a:extLst>
             </a:blip>
@@ -12001,10 +11969,10 @@
             <p:nvPr/>
           </p:nvPicPr>
           <p:blipFill>
-            <a:blip r:embed="rId18">
+            <a:blip>
               <a:extLst>
                 <a:ext uri="{96DAC541-7B7A-43D3-8B79-37D633B846F1}">
-                  <asvg:svgBlip xmlns:asvg="http://schemas.microsoft.com/office/drawing/2016/SVG/main" r:embed="rId19"/>
+                  <asvg:svgBlip xmlns:asvg="http://schemas.microsoft.com/office/drawing/2016/SVG/main" r:embed="rId11"/>
                 </a:ext>
               </a:extLst>
             </a:blip>
@@ -12260,10 +12228,10 @@
           <p:nvPr/>
         </p:nvPicPr>
         <p:blipFill>
-          <a:blip r:embed="rId16">
+          <a:blip>
             <a:extLst>
               <a:ext uri="{96DAC541-7B7A-43D3-8B79-37D633B846F1}">
-                <asvg:svgBlip xmlns:asvg="http://schemas.microsoft.com/office/drawing/2016/SVG/main" r:embed="rId17"/>
+                <asvg:svgBlip xmlns:asvg="http://schemas.microsoft.com/office/drawing/2016/SVG/main" r:embed="rId10"/>
               </a:ext>
             </a:extLst>
           </a:blip>
@@ -12370,10 +12338,10 @@
             <p:nvPr/>
           </p:nvPicPr>
           <p:blipFill>
-            <a:blip r:embed="rId16">
+            <a:blip>
               <a:extLst>
                 <a:ext uri="{96DAC541-7B7A-43D3-8B79-37D633B846F1}">
-                  <asvg:svgBlip xmlns:asvg="http://schemas.microsoft.com/office/drawing/2016/SVG/main" r:embed="rId17"/>
+                  <asvg:svgBlip xmlns:asvg="http://schemas.microsoft.com/office/drawing/2016/SVG/main" r:embed="rId10"/>
                 </a:ext>
               </a:extLst>
             </a:blip>
@@ -12406,10 +12374,10 @@
             <p:nvPr/>
           </p:nvPicPr>
           <p:blipFill>
-            <a:blip r:embed="rId18">
+            <a:blip>
               <a:extLst>
                 <a:ext uri="{96DAC541-7B7A-43D3-8B79-37D633B846F1}">
-                  <asvg:svgBlip xmlns:asvg="http://schemas.microsoft.com/office/drawing/2016/SVG/main" r:embed="rId19"/>
+                  <asvg:svgBlip xmlns:asvg="http://schemas.microsoft.com/office/drawing/2016/SVG/main" r:embed="rId11"/>
                 </a:ext>
               </a:extLst>
             </a:blip>
@@ -12517,10 +12485,10 @@
             <p:nvPr/>
           </p:nvPicPr>
           <p:blipFill>
-            <a:blip r:embed="rId16">
+            <a:blip>
               <a:extLst>
                 <a:ext uri="{96DAC541-7B7A-43D3-8B79-37D633B846F1}">
-                  <asvg:svgBlip xmlns:asvg="http://schemas.microsoft.com/office/drawing/2016/SVG/main" r:embed="rId17"/>
+                  <asvg:svgBlip xmlns:asvg="http://schemas.microsoft.com/office/drawing/2016/SVG/main" r:embed="rId10"/>
                 </a:ext>
               </a:extLst>
             </a:blip>
@@ -12553,10 +12521,10 @@
             <p:nvPr/>
           </p:nvPicPr>
           <p:blipFill>
-            <a:blip r:embed="rId18">
+            <a:blip>
               <a:extLst>
                 <a:ext uri="{96DAC541-7B7A-43D3-8B79-37D633B846F1}">
-                  <asvg:svgBlip xmlns:asvg="http://schemas.microsoft.com/office/drawing/2016/SVG/main" r:embed="rId19"/>
+                  <asvg:svgBlip xmlns:asvg="http://schemas.microsoft.com/office/drawing/2016/SVG/main" r:embed="rId11"/>
                 </a:ext>
               </a:extLst>
             </a:blip>
@@ -13358,10 +13326,10 @@
             <p:nvPr/>
           </p:nvPicPr>
           <p:blipFill>
-            <a:blip r:embed="rId16">
+            <a:blip>
               <a:extLst>
                 <a:ext uri="{96DAC541-7B7A-43D3-8B79-37D633B846F1}">
-                  <asvg:svgBlip xmlns:asvg="http://schemas.microsoft.com/office/drawing/2016/SVG/main" r:embed="rId17"/>
+                  <asvg:svgBlip xmlns:asvg="http://schemas.microsoft.com/office/drawing/2016/SVG/main" r:embed="rId10"/>
                 </a:ext>
               </a:extLst>
             </a:blip>
@@ -13394,10 +13362,10 @@
             <p:nvPr/>
           </p:nvPicPr>
           <p:blipFill>
-            <a:blip r:embed="rId18">
+            <a:blip>
               <a:extLst>
                 <a:ext uri="{96DAC541-7B7A-43D3-8B79-37D633B846F1}">
-                  <asvg:svgBlip xmlns:asvg="http://schemas.microsoft.com/office/drawing/2016/SVG/main" r:embed="rId19"/>
+                  <asvg:svgBlip xmlns:asvg="http://schemas.microsoft.com/office/drawing/2016/SVG/main" r:embed="rId11"/>
                 </a:ext>
               </a:extLst>
             </a:blip>
@@ -13451,10 +13419,10 @@
             <p:nvPr/>
           </p:nvPicPr>
           <p:blipFill>
-            <a:blip r:embed="rId16">
+            <a:blip>
               <a:extLst>
                 <a:ext uri="{96DAC541-7B7A-43D3-8B79-37D633B846F1}">
-                  <asvg:svgBlip xmlns:asvg="http://schemas.microsoft.com/office/drawing/2016/SVG/main" r:embed="rId17"/>
+                  <asvg:svgBlip xmlns:asvg="http://schemas.microsoft.com/office/drawing/2016/SVG/main" r:embed="rId10"/>
                 </a:ext>
               </a:extLst>
             </a:blip>
@@ -13700,10 +13668,10 @@
             <p:nvPr/>
           </p:nvPicPr>
           <p:blipFill>
-            <a:blip r:embed="rId16">
+            <a:blip>
               <a:extLst>
                 <a:ext uri="{96DAC541-7B7A-43D3-8B79-37D633B846F1}">
-                  <asvg:svgBlip xmlns:asvg="http://schemas.microsoft.com/office/drawing/2016/SVG/main" r:embed="rId17"/>
+                  <asvg:svgBlip xmlns:asvg="http://schemas.microsoft.com/office/drawing/2016/SVG/main" r:embed="rId10"/>
                 </a:ext>
               </a:extLst>
             </a:blip>
@@ -13736,10 +13704,10 @@
             <p:nvPr/>
           </p:nvPicPr>
           <p:blipFill>
-            <a:blip r:embed="rId18">
+            <a:blip>
               <a:extLst>
                 <a:ext uri="{96DAC541-7B7A-43D3-8B79-37D633B846F1}">
-                  <asvg:svgBlip xmlns:asvg="http://schemas.microsoft.com/office/drawing/2016/SVG/main" r:embed="rId19"/>
+                  <asvg:svgBlip xmlns:asvg="http://schemas.microsoft.com/office/drawing/2016/SVG/main" r:embed="rId11"/>
                 </a:ext>
               </a:extLst>
             </a:blip>
@@ -14202,10 +14170,10 @@
           <p:nvPr/>
         </p:nvPicPr>
         <p:blipFill>
-          <a:blip r:embed="rId18">
+          <a:blip>
             <a:extLst>
               <a:ext uri="{96DAC541-7B7A-43D3-8B79-37D633B846F1}">
-                <asvg:svgBlip xmlns:asvg="http://schemas.microsoft.com/office/drawing/2016/SVG/main" r:embed="rId19"/>
+                <asvg:svgBlip xmlns:asvg="http://schemas.microsoft.com/office/drawing/2016/SVG/main" r:embed="rId11"/>
               </a:ext>
             </a:extLst>
           </a:blip>
@@ -14284,7 +14252,7 @@
           <p:nvPr/>
         </p:nvPicPr>
         <p:blipFill>
-          <a:blip r:embed="rId22"/>
+          <a:blip r:embed="rId13"/>
           <a:srcRect/>
           <a:stretch/>
         </p:blipFill>
@@ -14313,7 +14281,7 @@
           <p:nvPr/>
         </p:nvPicPr>
         <p:blipFill>
-          <a:blip r:embed="rId23"/>
+          <a:blip r:embed="rId14"/>
           <a:srcRect/>
           <a:stretch/>
         </p:blipFill>
@@ -16940,7 +16908,7 @@
               <a:rPr lang="en-GB" sz="300" dirty="0">
                 <a:latin typeface="LM Roman 9" panose="00000500000000000000" pitchFamily="50" charset="0"/>
               </a:rPr>
-              <a:t>Hospital Occupancy &gt; 95% of Capacity?</a:t>
+              <a:t>Hospital Occupancy Approaching Capacity?</a:t>
             </a:r>
           </a:p>
         </p:txBody>
@@ -19547,7 +19515,7 @@
               <a:rPr lang="en-GB" sz="300" dirty="0">
                 <a:latin typeface="LM Roman 9" panose="00000500000000000000" pitchFamily="50" charset="0"/>
               </a:rPr>
-              <a:t>Hospital Occupancy &gt; 95% of Capacity?</a:t>
+              <a:t>Hospital Occupancy Approaching Capacity?</a:t>
             </a:r>
           </a:p>
         </p:txBody>
@@ -19859,10 +19827,10 @@
           <p:nvPr/>
         </p:nvPicPr>
         <p:blipFill>
-          <a:blip r:embed="rId24">
+          <a:blip>
             <a:extLst>
               <a:ext uri="{96DAC541-7B7A-43D3-8B79-37D633B846F1}">
-                <asvg:svgBlip xmlns:asvg="http://schemas.microsoft.com/office/drawing/2016/SVG/main" r:embed="rId25"/>
+                <asvg:svgBlip xmlns:asvg="http://schemas.microsoft.com/office/drawing/2016/SVG/main" r:embed="rId15"/>
               </a:ext>
             </a:extLst>
           </a:blip>
@@ -19895,10 +19863,10 @@
           <p:nvPr/>
         </p:nvPicPr>
         <p:blipFill>
-          <a:blip r:embed="rId26">
+          <a:blip>
             <a:extLst>
               <a:ext uri="{96DAC541-7B7A-43D3-8B79-37D633B846F1}">
-                <asvg:svgBlip xmlns:asvg="http://schemas.microsoft.com/office/drawing/2016/SVG/main" r:embed="rId27"/>
+                <asvg:svgBlip xmlns:asvg="http://schemas.microsoft.com/office/drawing/2016/SVG/main" r:embed="rId16"/>
               </a:ext>
             </a:extLst>
           </a:blip>
@@ -19931,10 +19899,10 @@
           <p:nvPr/>
         </p:nvPicPr>
         <p:blipFill>
-          <a:blip r:embed="rId28">
+          <a:blip>
             <a:extLst>
               <a:ext uri="{96DAC541-7B7A-43D3-8B79-37D633B846F1}">
-                <asvg:svgBlip xmlns:asvg="http://schemas.microsoft.com/office/drawing/2016/SVG/main" r:embed="rId29"/>
+                <asvg:svgBlip xmlns:asvg="http://schemas.microsoft.com/office/drawing/2016/SVG/main" r:embed="rId17"/>
               </a:ext>
             </a:extLst>
           </a:blip>
@@ -20041,10 +20009,10 @@
           <p:nvPr/>
         </p:nvPicPr>
         <p:blipFill>
-          <a:blip r:embed="rId30">
+          <a:blip>
             <a:extLst>
               <a:ext uri="{96DAC541-7B7A-43D3-8B79-37D633B846F1}">
-                <asvg:svgBlip xmlns:asvg="http://schemas.microsoft.com/office/drawing/2016/SVG/main" r:embed="rId31"/>
+                <asvg:svgBlip xmlns:asvg="http://schemas.microsoft.com/office/drawing/2016/SVG/main" r:embed="rId18"/>
               </a:ext>
             </a:extLst>
           </a:blip>
@@ -23681,10 +23649,10 @@
           <p:nvPr/>
         </p:nvPicPr>
         <p:blipFill>
-          <a:blip r:embed="rId32">
+          <a:blip>
             <a:extLst>
               <a:ext uri="{96DAC541-7B7A-43D3-8B79-37D633B846F1}">
-                <asvg:svgBlip xmlns:asvg="http://schemas.microsoft.com/office/drawing/2016/SVG/main" r:embed="rId33"/>
+                <asvg:svgBlip xmlns:asvg="http://schemas.microsoft.com/office/drawing/2016/SVG/main" r:embed="rId19"/>
               </a:ext>
             </a:extLst>
           </a:blip>
@@ -24114,10 +24082,10 @@
             <p:nvPr/>
           </p:nvPicPr>
           <p:blipFill>
-            <a:blip r:embed="rId34">
+            <a:blip>
               <a:extLst>
                 <a:ext uri="{96DAC541-7B7A-43D3-8B79-37D633B846F1}">
-                  <asvg:svgBlip xmlns:asvg="http://schemas.microsoft.com/office/drawing/2016/SVG/main" r:embed="rId35"/>
+                  <asvg:svgBlip xmlns:asvg="http://schemas.microsoft.com/office/drawing/2016/SVG/main" r:embed="rId20"/>
                 </a:ext>
               </a:extLst>
             </a:blip>
@@ -24150,10 +24118,10 @@
             <p:nvPr/>
           </p:nvPicPr>
           <p:blipFill>
-            <a:blip r:embed="rId36">
+            <a:blip>
               <a:extLst>
                 <a:ext uri="{96DAC541-7B7A-43D3-8B79-37D633B846F1}">
-                  <asvg:svgBlip xmlns:asvg="http://schemas.microsoft.com/office/drawing/2016/SVG/main" r:embed="rId37"/>
+                  <asvg:svgBlip xmlns:asvg="http://schemas.microsoft.com/office/drawing/2016/SVG/main" r:embed="rId21"/>
                 </a:ext>
               </a:extLst>
             </a:blip>
@@ -24210,10 +24178,10 @@
             <p:nvPr/>
           </p:nvPicPr>
           <p:blipFill>
-            <a:blip r:embed="rId34">
+            <a:blip>
               <a:extLst>
                 <a:ext uri="{96DAC541-7B7A-43D3-8B79-37D633B846F1}">
-                  <asvg:svgBlip xmlns:asvg="http://schemas.microsoft.com/office/drawing/2016/SVG/main" r:embed="rId35"/>
+                  <asvg:svgBlip xmlns:asvg="http://schemas.microsoft.com/office/drawing/2016/SVG/main" r:embed="rId20"/>
                 </a:ext>
               </a:extLst>
             </a:blip>
@@ -24246,10 +24214,10 @@
             <p:nvPr/>
           </p:nvPicPr>
           <p:blipFill>
-            <a:blip r:embed="rId36">
+            <a:blip>
               <a:extLst>
                 <a:ext uri="{96DAC541-7B7A-43D3-8B79-37D633B846F1}">
-                  <asvg:svgBlip xmlns:asvg="http://schemas.microsoft.com/office/drawing/2016/SVG/main" r:embed="rId37"/>
+                  <asvg:svgBlip xmlns:asvg="http://schemas.microsoft.com/office/drawing/2016/SVG/main" r:embed="rId21"/>
                 </a:ext>
               </a:extLst>
             </a:blip>
@@ -24650,10 +24618,10 @@
           <p:nvPr/>
         </p:nvPicPr>
         <p:blipFill>
-          <a:blip r:embed="rId38">
+          <a:blip>
             <a:extLst>
               <a:ext uri="{96DAC541-7B7A-43D3-8B79-37D633B846F1}">
-                <asvg:svgBlip xmlns:asvg="http://schemas.microsoft.com/office/drawing/2016/SVG/main" r:embed="rId39"/>
+                <asvg:svgBlip xmlns:asvg="http://schemas.microsoft.com/office/drawing/2016/SVG/main" r:embed="rId22"/>
               </a:ext>
             </a:extLst>
           </a:blip>
@@ -24686,10 +24654,10 @@
           <p:nvPr/>
         </p:nvPicPr>
         <p:blipFill>
-          <a:blip r:embed="rId40">
+          <a:blip>
             <a:extLst>
               <a:ext uri="{96DAC541-7B7A-43D3-8B79-37D633B846F1}">
-                <asvg:svgBlip xmlns:asvg="http://schemas.microsoft.com/office/drawing/2016/SVG/main" r:embed="rId41"/>
+                <asvg:svgBlip xmlns:asvg="http://schemas.microsoft.com/office/drawing/2016/SVG/main" r:embed="rId23"/>
               </a:ext>
             </a:extLst>
           </a:blip>
@@ -24722,10 +24690,10 @@
           <p:nvPr/>
         </p:nvPicPr>
         <p:blipFill>
-          <a:blip r:embed="rId42">
+          <a:blip>
             <a:extLst>
               <a:ext uri="{96DAC541-7B7A-43D3-8B79-37D633B846F1}">
-                <asvg:svgBlip xmlns:asvg="http://schemas.microsoft.com/office/drawing/2016/SVG/main" r:embed="rId43"/>
+                <asvg:svgBlip xmlns:asvg="http://schemas.microsoft.com/office/drawing/2016/SVG/main" r:embed="rId24"/>
               </a:ext>
             </a:extLst>
           </a:blip>
@@ -24758,10 +24726,10 @@
           <p:nvPr/>
         </p:nvPicPr>
         <p:blipFill>
-          <a:blip r:embed="rId44">
+          <a:blip>
             <a:extLst>
               <a:ext uri="{96DAC541-7B7A-43D3-8B79-37D633B846F1}">
-                <asvg:svgBlip xmlns:asvg="http://schemas.microsoft.com/office/drawing/2016/SVG/main" r:embed="rId45"/>
+                <asvg:svgBlip xmlns:asvg="http://schemas.microsoft.com/office/drawing/2016/SVG/main" r:embed="rId25"/>
               </a:ext>
             </a:extLst>
           </a:blip>
@@ -24794,10 +24762,10 @@
           <p:nvPr/>
         </p:nvPicPr>
         <p:blipFill>
-          <a:blip r:embed="rId46">
+          <a:blip>
             <a:extLst>
               <a:ext uri="{96DAC541-7B7A-43D3-8B79-37D633B846F1}">
-                <asvg:svgBlip xmlns:asvg="http://schemas.microsoft.com/office/drawing/2016/SVG/main" r:embed="rId47"/>
+                <asvg:svgBlip xmlns:asvg="http://schemas.microsoft.com/office/drawing/2016/SVG/main" r:embed="rId26"/>
               </a:ext>
             </a:extLst>
           </a:blip>
@@ -25064,10 +25032,10 @@
             <p:nvPr/>
           </p:nvPicPr>
           <p:blipFill>
-            <a:blip r:embed="rId48">
+            <a:blip>
               <a:extLst>
                 <a:ext uri="{96DAC541-7B7A-43D3-8B79-37D633B846F1}">
-                  <asvg:svgBlip xmlns:asvg="http://schemas.microsoft.com/office/drawing/2016/SVG/main" r:embed="rId49"/>
+                  <asvg:svgBlip xmlns:asvg="http://schemas.microsoft.com/office/drawing/2016/SVG/main" r:embed="rId27"/>
                 </a:ext>
               </a:extLst>
             </a:blip>
@@ -25100,10 +25068,10 @@
             <p:nvPr/>
           </p:nvPicPr>
           <p:blipFill>
-            <a:blip r:embed="rId50">
+            <a:blip>
               <a:extLst>
                 <a:ext uri="{96DAC541-7B7A-43D3-8B79-37D633B846F1}">
-                  <asvg:svgBlip xmlns:asvg="http://schemas.microsoft.com/office/drawing/2016/SVG/main" r:embed="rId51"/>
+                  <asvg:svgBlip xmlns:asvg="http://schemas.microsoft.com/office/drawing/2016/SVG/main" r:embed="rId28"/>
                 </a:ext>
               </a:extLst>
             </a:blip>
@@ -25160,10 +25128,10 @@
             <p:nvPr/>
           </p:nvPicPr>
           <p:blipFill>
-            <a:blip r:embed="rId48">
+            <a:blip>
               <a:extLst>
                 <a:ext uri="{96DAC541-7B7A-43D3-8B79-37D633B846F1}">
-                  <asvg:svgBlip xmlns:asvg="http://schemas.microsoft.com/office/drawing/2016/SVG/main" r:embed="rId49"/>
+                  <asvg:svgBlip xmlns:asvg="http://schemas.microsoft.com/office/drawing/2016/SVG/main" r:embed="rId27"/>
                 </a:ext>
               </a:extLst>
             </a:blip>
@@ -25196,10 +25164,10 @@
             <p:nvPr/>
           </p:nvPicPr>
           <p:blipFill>
-            <a:blip r:embed="rId50">
+            <a:blip>
               <a:extLst>
                 <a:ext uri="{96DAC541-7B7A-43D3-8B79-37D633B846F1}">
-                  <asvg:svgBlip xmlns:asvg="http://schemas.microsoft.com/office/drawing/2016/SVG/main" r:embed="rId51"/>
+                  <asvg:svgBlip xmlns:asvg="http://schemas.microsoft.com/office/drawing/2016/SVG/main" r:embed="rId28"/>
                 </a:ext>
               </a:extLst>
             </a:blip>
@@ -25600,10 +25568,10 @@
           <p:nvPr/>
         </p:nvPicPr>
         <p:blipFill>
-          <a:blip r:embed="rId52">
+          <a:blip>
             <a:extLst>
               <a:ext uri="{96DAC541-7B7A-43D3-8B79-37D633B846F1}">
-                <asvg:svgBlip xmlns:asvg="http://schemas.microsoft.com/office/drawing/2016/SVG/main" r:embed="rId53"/>
+                <asvg:svgBlip xmlns:asvg="http://schemas.microsoft.com/office/drawing/2016/SVG/main" r:embed="rId29"/>
               </a:ext>
             </a:extLst>
           </a:blip>
@@ -25636,10 +25604,10 @@
           <p:nvPr/>
         </p:nvPicPr>
         <p:blipFill>
-          <a:blip r:embed="rId54">
+          <a:blip>
             <a:extLst>
               <a:ext uri="{96DAC541-7B7A-43D3-8B79-37D633B846F1}">
-                <asvg:svgBlip xmlns:asvg="http://schemas.microsoft.com/office/drawing/2016/SVG/main" r:embed="rId55"/>
+                <asvg:svgBlip xmlns:asvg="http://schemas.microsoft.com/office/drawing/2016/SVG/main" r:embed="rId30"/>
               </a:ext>
             </a:extLst>
           </a:blip>

</xml_diff>